<commit_message>
chore: remove outdated PDF file and update PowerPoint and diagram generation scripts to improve layout and spacing for better presentation of workshop content
</commit_message>
<xml_diff>
--- a/web-presentation/pdf-exports/ETRA-AI-Tools-Workshop-3Days-AR.pptx
+++ b/web-presentation/pdf-exports/ETRA-AI-Tools-Workshop-3Days-AR.pptx
@@ -3492,7 +3492,7 @@
         <p:spPr>
           <a:xfrm>
             <a:off x="548640" y="1371600"/>
-            <a:ext cx="5120640" cy="2726713"/>
+            <a:ext cx="5120640" cy="3021240"/>
           </a:xfrm>
           <a:prstGeom prst="rect">
             <a:avLst/>
@@ -5810,7 +5810,7 @@
         <p:spPr>
           <a:xfrm>
             <a:off x="548640" y="1856202739200"/>
-            <a:ext cx="5212080" cy="2769984"/>
+            <a:ext cx="5212080" cy="3075191"/>
           </a:xfrm>
           <a:prstGeom prst="rect">
             <a:avLst/>
@@ -6212,8 +6212,8 @@
         </p:blipFill>
         <p:spPr>
           <a:xfrm>
-            <a:off x="2209499" y="1965960"/>
-            <a:ext cx="7742521" cy="4114800"/>
+            <a:off x="2477479" y="1874519"/>
+            <a:ext cx="7206561" cy="4251960"/>
           </a:xfrm>
           <a:prstGeom prst="rect">
             <a:avLst/>
@@ -12165,8 +12165,8 @@
         </p:blipFill>
         <p:spPr>
           <a:xfrm>
-            <a:off x="2209499" y="1965960"/>
-            <a:ext cx="7742521" cy="4114800"/>
+            <a:off x="2593714" y="1965960"/>
+            <a:ext cx="6974091" cy="4114800"/>
           </a:xfrm>
           <a:prstGeom prst="rect">
             <a:avLst/>
@@ -14440,8 +14440,8 @@
         </p:blipFill>
         <p:spPr>
           <a:xfrm>
-            <a:off x="2209499" y="1965960"/>
-            <a:ext cx="7742521" cy="4114800"/>
+            <a:off x="2477479" y="1874519"/>
+            <a:ext cx="7206561" cy="4251960"/>
           </a:xfrm>
           <a:prstGeom prst="rect">
             <a:avLst/>
@@ -15694,7 +15694,7 @@
         <p:spPr>
           <a:xfrm>
             <a:off x="548640" y="1856202739200"/>
-            <a:ext cx="5212080" cy="2769984"/>
+            <a:ext cx="5212080" cy="3075191"/>
           </a:xfrm>
           <a:prstGeom prst="rect">
             <a:avLst/>
@@ -16096,8 +16096,8 @@
         </p:blipFill>
         <p:spPr>
           <a:xfrm>
-            <a:off x="2209499" y="1965960"/>
-            <a:ext cx="7742521" cy="4114800"/>
+            <a:off x="2477479" y="1874519"/>
+            <a:ext cx="7206561" cy="4251960"/>
           </a:xfrm>
           <a:prstGeom prst="rect">
             <a:avLst/>
@@ -20110,8 +20110,8 @@
         </p:blipFill>
         <p:spPr>
           <a:xfrm>
-            <a:off x="2209499" y="1965960"/>
-            <a:ext cx="7742521" cy="4114800"/>
+            <a:off x="2477479" y="1874519"/>
+            <a:ext cx="7206561" cy="4251960"/>
           </a:xfrm>
           <a:prstGeom prst="rect">
             <a:avLst/>
@@ -24843,8 +24843,8 @@
         </p:blipFill>
         <p:spPr>
           <a:xfrm>
-            <a:off x="2209499" y="1965960"/>
-            <a:ext cx="7742521" cy="4114800"/>
+            <a:off x="2477479" y="1874519"/>
+            <a:ext cx="7206561" cy="4251960"/>
           </a:xfrm>
           <a:prstGeom prst="rect">
             <a:avLst/>
@@ -26097,7 +26097,7 @@
         <p:spPr>
           <a:xfrm>
             <a:off x="548640" y="1856202739200"/>
-            <a:ext cx="5212080" cy="2769984"/>
+            <a:ext cx="5212080" cy="3075191"/>
           </a:xfrm>
           <a:prstGeom prst="rect">
             <a:avLst/>
@@ -33511,8 +33511,8 @@
         </p:blipFill>
         <p:spPr>
           <a:xfrm>
-            <a:off x="2209499" y="1965960"/>
-            <a:ext cx="7742521" cy="4114800"/>
+            <a:off x="2477479" y="1874519"/>
+            <a:ext cx="7206561" cy="4251960"/>
           </a:xfrm>
           <a:prstGeom prst="rect">
             <a:avLst/>
@@ -36161,8 +36161,8 @@
         </p:blipFill>
         <p:spPr>
           <a:xfrm>
-            <a:off x="2209499" y="1965960"/>
-            <a:ext cx="7742521" cy="4114800"/>
+            <a:off x="2477479" y="1874519"/>
+            <a:ext cx="7206561" cy="4251960"/>
           </a:xfrm>
           <a:prstGeom prst="rect">
             <a:avLst/>
@@ -41148,8 +41148,8 @@
         </p:blipFill>
         <p:spPr>
           <a:xfrm>
-            <a:off x="2209499" y="1965960"/>
-            <a:ext cx="7742521" cy="4114800"/>
+            <a:off x="2477479" y="1874519"/>
+            <a:ext cx="7206561" cy="4251960"/>
           </a:xfrm>
           <a:prstGeom prst="rect">
             <a:avLst/>
@@ -42191,7 +42191,7 @@
         <p:spPr>
           <a:xfrm>
             <a:off x="548640" y="1630448352000"/>
-            <a:ext cx="5212080" cy="2769984"/>
+            <a:ext cx="5212080" cy="3075191"/>
           </a:xfrm>
           <a:prstGeom prst="rect">
             <a:avLst/>
@@ -44839,8 +44839,8 @@
         </p:blipFill>
         <p:spPr>
           <a:xfrm>
-            <a:off x="2209499" y="1965960"/>
-            <a:ext cx="7742521" cy="4114800"/>
+            <a:off x="2477479" y="1874519"/>
+            <a:ext cx="7206561" cy="4251960"/>
           </a:xfrm>
           <a:prstGeom prst="rect">
             <a:avLst/>
@@ -50163,8 +50163,8 @@
         </p:blipFill>
         <p:spPr>
           <a:xfrm>
-            <a:off x="2209499" y="1965960"/>
-            <a:ext cx="7742521" cy="4114800"/>
+            <a:off x="2477479" y="1874519"/>
+            <a:ext cx="7206561" cy="4251960"/>
           </a:xfrm>
           <a:prstGeom prst="rect">
             <a:avLst/>
@@ -51625,8 +51625,8 @@
         </p:blipFill>
         <p:spPr>
           <a:xfrm>
-            <a:off x="2209499" y="1965960"/>
-            <a:ext cx="7742521" cy="4114800"/>
+            <a:off x="2477479" y="1874519"/>
+            <a:ext cx="7206561" cy="4251960"/>
           </a:xfrm>
           <a:prstGeom prst="rect">
             <a:avLst/>
@@ -52668,7 +52668,7 @@
         <p:spPr>
           <a:xfrm>
             <a:off x="548640" y="1630448352000"/>
-            <a:ext cx="5212080" cy="2769984"/>
+            <a:ext cx="5212080" cy="3075191"/>
           </a:xfrm>
           <a:prstGeom prst="rect">
             <a:avLst/>
@@ -53752,8 +53752,8 @@
         </p:blipFill>
         <p:spPr>
           <a:xfrm>
-            <a:off x="2209499" y="1965960"/>
-            <a:ext cx="7742521" cy="4114800"/>
+            <a:off x="2477479" y="1874519"/>
+            <a:ext cx="7206561" cy="4251960"/>
           </a:xfrm>
           <a:prstGeom prst="rect">
             <a:avLst/>
@@ -54155,8 +54155,8 @@
         </p:blipFill>
         <p:spPr>
           <a:xfrm>
-            <a:off x="2209499" y="1965960"/>
-            <a:ext cx="7742521" cy="4114800"/>
+            <a:off x="2477479" y="1874519"/>
+            <a:ext cx="7206561" cy="4251960"/>
           </a:xfrm>
           <a:prstGeom prst="rect">
             <a:avLst/>

</xml_diff>

<commit_message>
feat: update PowerPoint and diagram generation scripts to refine subtitles and improve layout for workshop content, enhancing clarity and presentation quality
</commit_message>
<xml_diff>
--- a/web-presentation/pdf-exports/ETRA-AI-Tools-Workshop-3Days-AR.pptx
+++ b/web-presentation/pdf-exports/ETRA-AI-Tools-Workshop-3Days-AR.pptx
@@ -3249,8 +3249,8 @@
         </p:nvSpPr>
         <p:spPr>
           <a:xfrm>
-            <a:off x="5852160" y="1554480"/>
-            <a:ext cx="5669280" cy="365760"/>
+            <a:off x="548640" y="1874519"/>
+            <a:ext cx="10972800" cy="365760"/>
           </a:xfrm>
           <a:prstGeom prst="rect">
             <a:avLst/>
@@ -3269,7 +3269,7 @@
               </a:spcAft>
             </a:pPr>
             <a:r>
-              <a:rPr sz="1500" b="1" rtl="1" lang="ar-SA" altLang="en-US">
+              <a:rPr sz="1600" b="1" rtl="1" lang="ar-SA" altLang="en-US">
                 <a:solidFill>
                   <a:srgbClr val="9E59CD"/>
                 </a:solidFill>
@@ -3290,8 +3290,8 @@
         </p:nvSpPr>
         <p:spPr>
           <a:xfrm>
-            <a:off x="5852160" y="2011680"/>
-            <a:ext cx="5669280" cy="1280160"/>
+            <a:off x="548640" y="2331720"/>
+            <a:ext cx="10972800" cy="1005840"/>
           </a:xfrm>
           <a:prstGeom prst="rect">
             <a:avLst/>
@@ -3310,7 +3310,7 @@
               </a:spcAft>
             </a:pPr>
             <a:r>
-              <a:rPr sz="2800" b="1" rtl="1" lang="ar-SA" altLang="en-US">
+              <a:rPr sz="3600" b="1" rtl="1" lang="ar-SA" altLang="en-US">
                 <a:solidFill>
                   <a:srgbClr val="5234B7"/>
                 </a:solidFill>
@@ -3328,7 +3328,7 @@
               </a:spcAft>
             </a:pPr>
             <a:r>
-              <a:rPr sz="2800" b="1" rtl="1" lang="ar-SA" altLang="en-US">
+              <a:rPr sz="3600" b="1" rtl="1" lang="ar-SA" altLang="en-US">
                 <a:solidFill>
                   <a:srgbClr val="5234B7"/>
                 </a:solidFill>
@@ -3349,8 +3349,8 @@
         </p:nvSpPr>
         <p:spPr>
           <a:xfrm>
-            <a:off x="10149840" y="3520440"/>
-            <a:ext cx="1280160" cy="64008"/>
+            <a:off x="9418320" y="4434840"/>
+            <a:ext cx="1371600" cy="64008"/>
           </a:xfrm>
           <a:prstGeom prst="rect">
             <a:avLst/>
@@ -3401,8 +3401,8 @@
         </p:nvSpPr>
         <p:spPr>
           <a:xfrm>
-            <a:off x="5852160" y="3794760"/>
-            <a:ext cx="5669280" cy="640080"/>
+            <a:off x="548640" y="4663440"/>
+            <a:ext cx="10972800" cy="457200"/>
           </a:xfrm>
           <a:prstGeom prst="rect">
             <a:avLst/>
@@ -3421,7 +3421,7 @@
               </a:spcAft>
             </a:pPr>
             <a:r>
-              <a:rPr sz="1400" b="0" rtl="1" lang="ar-SA" altLang="en-US">
+              <a:rPr sz="1600" b="0" rtl="1" lang="ar-SA" altLang="en-US">
                 <a:solidFill>
                   <a:srgbClr val="5A5470"/>
                 </a:solidFill>
@@ -3475,30 +3475,6 @@
           </a:p>
         </p:txBody>
       </p:sp>
-      <p:pic>
-        <p:nvPicPr>
-          <p:cNvPr id="9" name="Picture 8" descr="cover-hero.png"/>
-          <p:cNvPicPr>
-            <a:picLocks noChangeAspect="1"/>
-          </p:cNvPicPr>
-          <p:nvPr/>
-        </p:nvPicPr>
-        <p:blipFill>
-          <a:blip r:embed="rId3"/>
-          <a:stretch>
-            <a:fillRect/>
-          </a:stretch>
-        </p:blipFill>
-        <p:spPr>
-          <a:xfrm>
-            <a:off x="548640" y="1371600"/>
-            <a:ext cx="5120640" cy="3021240"/>
-          </a:xfrm>
-          <a:prstGeom prst="rect">
-            <a:avLst/>
-          </a:prstGeom>
-        </p:spPr>
-      </p:pic>
     </p:spTree>
   </p:cSld>
   <p:clrMapOvr>
@@ -8511,48 +8487,7 @@
       </p:sp>
       <p:sp>
         <p:nvSpPr>
-          <p:cNvPr id="10" name="TextBox 9"/>
-          <p:cNvSpPr txBox="1"/>
-          <p:nvPr/>
-        </p:nvSpPr>
-        <p:spPr>
-          <a:xfrm>
-            <a:off x="548640" y="1591056"/>
-            <a:ext cx="10972800" cy="365760"/>
-          </a:xfrm>
-          <a:prstGeom prst="rect">
-            <a:avLst/>
-          </a:prstGeom>
-          <a:noFill/>
-        </p:spPr>
-        <p:txBody>
-          <a:bodyPr wrap="square" anchor="t">
-            <a:spAutoFit/>
-          </a:bodyPr>
-          <a:lstStyle/>
-          <a:p>
-            <a:pPr algn="r" rtl="1">
-              <a:spcAft>
-                <a:spcPts val="400"/>
-              </a:spcAft>
-            </a:pPr>
-            <a:r>
-              <a:rPr sz="1400" b="0" rtl="1" lang="ar-SA" altLang="en-US">
-                <a:solidFill>
-                  <a:srgbClr val="5A5470"/>
-                </a:solidFill>
-                <a:latin typeface="IBM Plex Sans Arabic"/>
-                <a:ea typeface="IBM Plex Sans Arabic"/>
-                <a:cs typeface="IBM Plex Sans Arabic"/>
-              </a:rPr>
-              <a:t>المدة: ساعة</a:t>
-            </a:r>
-          </a:p>
-        </p:txBody>
-      </p:sp>
-      <p:sp>
-        <p:nvSpPr>
-          <p:cNvPr id="11" name="Rounded Rectangle 10"/>
+          <p:cNvPr id="10" name="Rounded Rectangle 9"/>
           <p:cNvSpPr/>
           <p:nvPr/>
         </p:nvSpPr>
@@ -8598,7 +8533,7 @@
       </p:sp>
       <p:sp>
         <p:nvSpPr>
-          <p:cNvPr id="12" name="TextBox 11"/>
+          <p:cNvPr id="11" name="TextBox 10"/>
           <p:cNvSpPr txBox="1"/>
           <p:nvPr/>
         </p:nvSpPr>
@@ -8639,7 +8574,7 @@
       </p:sp>
       <p:sp>
         <p:nvSpPr>
-          <p:cNvPr id="13" name="TextBox 12"/>
+          <p:cNvPr id="12" name="TextBox 11"/>
           <p:cNvSpPr txBox="1"/>
           <p:nvPr/>
         </p:nvSpPr>
@@ -11603,48 +11538,7 @@
       </p:sp>
       <p:sp>
         <p:nvSpPr>
-          <p:cNvPr id="10" name="TextBox 9"/>
-          <p:cNvSpPr txBox="1"/>
-          <p:nvPr/>
-        </p:nvSpPr>
-        <p:spPr>
-          <a:xfrm>
-            <a:off x="548640" y="1591056"/>
-            <a:ext cx="10972800" cy="365760"/>
-          </a:xfrm>
-          <a:prstGeom prst="rect">
-            <a:avLst/>
-          </a:prstGeom>
-          <a:noFill/>
-        </p:spPr>
-        <p:txBody>
-          <a:bodyPr wrap="square" anchor="t">
-            <a:spAutoFit/>
-          </a:bodyPr>
-          <a:lstStyle/>
-          <a:p>
-            <a:pPr algn="r" rtl="1">
-              <a:spcAft>
-                <a:spcPts val="400"/>
-              </a:spcAft>
-            </a:pPr>
-            <a:r>
-              <a:rPr sz="1400" b="0" rtl="1" lang="ar-SA" altLang="en-US">
-                <a:solidFill>
-                  <a:srgbClr val="5A5470"/>
-                </a:solidFill>
-                <a:latin typeface="IBM Plex Sans Arabic"/>
-                <a:ea typeface="IBM Plex Sans Arabic"/>
-                <a:cs typeface="IBM Plex Sans Arabic"/>
-              </a:rPr>
-              <a:t>المدة: ساعة ونصف</a:t>
-            </a:r>
-          </a:p>
-        </p:txBody>
-      </p:sp>
-      <p:sp>
-        <p:nvSpPr>
-          <p:cNvPr id="11" name="Rounded Rectangle 10"/>
+          <p:cNvPr id="10" name="Rounded Rectangle 9"/>
           <p:cNvSpPr/>
           <p:nvPr/>
         </p:nvSpPr>
@@ -11690,7 +11584,7 @@
       </p:sp>
       <p:sp>
         <p:nvSpPr>
-          <p:cNvPr id="12" name="TextBox 11"/>
+          <p:cNvPr id="11" name="TextBox 10"/>
           <p:cNvSpPr txBox="1"/>
           <p:nvPr/>
         </p:nvSpPr>
@@ -11731,7 +11625,7 @@
       </p:sp>
       <p:sp>
         <p:nvSpPr>
-          <p:cNvPr id="13" name="TextBox 12"/>
+          <p:cNvPr id="12" name="TextBox 11"/>
           <p:cNvSpPr txBox="1"/>
           <p:nvPr/>
         </p:nvSpPr>
@@ -16075,7 +15969,7 @@
                 <a:ea typeface="IBM Plex Sans Arabic"/>
                 <a:cs typeface="IBM Plex Sans Arabic"/>
               </a:rPr>
-              <a:t>30 دقيقة — من PDF إلى إيميل وتغريدات</a:t>
+              <a:t>من PDF إلى إيميل وتغريدات</a:t>
             </a:r>
           </a:p>
         </p:txBody>
@@ -19295,7 +19189,7 @@
                 <a:ea typeface="IBM Plex Sans Arabic"/>
                 <a:cs typeface="IBM Plex Sans Arabic"/>
               </a:rPr>
-              <a:t>الجلسة 1  ·  ساعة ونصف</a:t>
+              <a:t>الجلسة 1</a:t>
             </a:r>
           </a:p>
         </p:txBody>
@@ -19423,7 +19317,7 @@
                 <a:ea typeface="IBM Plex Sans Arabic"/>
                 <a:cs typeface="IBM Plex Sans Arabic"/>
               </a:rPr>
-              <a:t>الجلسة 2  ·  ساعة</a:t>
+              <a:t>الجلسة 2</a:t>
             </a:r>
           </a:p>
         </p:txBody>
@@ -19551,7 +19445,7 @@
                 <a:ea typeface="IBM Plex Sans Arabic"/>
                 <a:cs typeface="IBM Plex Sans Arabic"/>
               </a:rPr>
-              <a:t>الجلسة 3  ·  ساعة ونصف</a:t>
+              <a:t>الجلسة 3</a:t>
             </a:r>
           </a:p>
         </p:txBody>
@@ -21687,48 +21581,7 @@
       </p:sp>
       <p:sp>
         <p:nvSpPr>
-          <p:cNvPr id="10" name="TextBox 9"/>
-          <p:cNvSpPr txBox="1"/>
-          <p:nvPr/>
-        </p:nvSpPr>
-        <p:spPr>
-          <a:xfrm>
-            <a:off x="548640" y="1591056"/>
-            <a:ext cx="10972800" cy="365760"/>
-          </a:xfrm>
-          <a:prstGeom prst="rect">
-            <a:avLst/>
-          </a:prstGeom>
-          <a:noFill/>
-        </p:spPr>
-        <p:txBody>
-          <a:bodyPr wrap="square" anchor="t">
-            <a:spAutoFit/>
-          </a:bodyPr>
-          <a:lstStyle/>
-          <a:p>
-            <a:pPr algn="r" rtl="1">
-              <a:spcAft>
-                <a:spcPts val="400"/>
-              </a:spcAft>
-            </a:pPr>
-            <a:r>
-              <a:rPr sz="1400" b="0" rtl="1" lang="ar-SA" altLang="en-US">
-                <a:solidFill>
-                  <a:srgbClr val="5A5470"/>
-                </a:solidFill>
-                <a:latin typeface="IBM Plex Sans Arabic"/>
-                <a:ea typeface="IBM Plex Sans Arabic"/>
-                <a:cs typeface="IBM Plex Sans Arabic"/>
-              </a:rPr>
-              <a:t>المدة: ساعة ونصف</a:t>
-            </a:r>
-          </a:p>
-        </p:txBody>
-      </p:sp>
-      <p:sp>
-        <p:nvSpPr>
-          <p:cNvPr id="11" name="Rounded Rectangle 10"/>
+          <p:cNvPr id="10" name="Rounded Rectangle 9"/>
           <p:cNvSpPr/>
           <p:nvPr/>
         </p:nvSpPr>
@@ -21774,7 +21627,7 @@
       </p:sp>
       <p:sp>
         <p:nvSpPr>
-          <p:cNvPr id="12" name="TextBox 11"/>
+          <p:cNvPr id="11" name="TextBox 10"/>
           <p:cNvSpPr txBox="1"/>
           <p:nvPr/>
         </p:nvSpPr>
@@ -21815,7 +21668,7 @@
       </p:sp>
       <p:sp>
         <p:nvSpPr>
-          <p:cNvPr id="13" name="TextBox 12"/>
+          <p:cNvPr id="12" name="TextBox 11"/>
           <p:cNvSpPr txBox="1"/>
           <p:nvPr/>
         </p:nvSpPr>
@@ -27207,48 +27060,7 @@
       </p:sp>
       <p:sp>
         <p:nvSpPr>
-          <p:cNvPr id="10" name="TextBox 9"/>
-          <p:cNvSpPr txBox="1"/>
-          <p:nvPr/>
-        </p:nvSpPr>
-        <p:spPr>
-          <a:xfrm>
-            <a:off x="548640" y="1591056"/>
-            <a:ext cx="10972800" cy="365760"/>
-          </a:xfrm>
-          <a:prstGeom prst="rect">
-            <a:avLst/>
-          </a:prstGeom>
-          <a:noFill/>
-        </p:spPr>
-        <p:txBody>
-          <a:bodyPr wrap="square" anchor="t">
-            <a:spAutoFit/>
-          </a:bodyPr>
-          <a:lstStyle/>
-          <a:p>
-            <a:pPr algn="r" rtl="1">
-              <a:spcAft>
-                <a:spcPts val="400"/>
-              </a:spcAft>
-            </a:pPr>
-            <a:r>
-              <a:rPr sz="1400" b="0" rtl="1" lang="ar-SA" altLang="en-US">
-                <a:solidFill>
-                  <a:srgbClr val="5A5470"/>
-                </a:solidFill>
-                <a:latin typeface="IBM Plex Sans Arabic"/>
-                <a:ea typeface="IBM Plex Sans Arabic"/>
-                <a:cs typeface="IBM Plex Sans Arabic"/>
-              </a:rPr>
-              <a:t>المدة: ساعة</a:t>
-            </a:r>
-          </a:p>
-        </p:txBody>
-      </p:sp>
-      <p:sp>
-        <p:nvSpPr>
-          <p:cNvPr id="11" name="Rounded Rectangle 10"/>
+          <p:cNvPr id="10" name="Rounded Rectangle 9"/>
           <p:cNvSpPr/>
           <p:nvPr/>
         </p:nvSpPr>
@@ -27294,7 +27106,7 @@
       </p:sp>
       <p:sp>
         <p:nvSpPr>
-          <p:cNvPr id="12" name="TextBox 11"/>
+          <p:cNvPr id="11" name="TextBox 10"/>
           <p:cNvSpPr txBox="1"/>
           <p:nvPr/>
         </p:nvSpPr>
@@ -27335,7 +27147,7 @@
       </p:sp>
       <p:sp>
         <p:nvSpPr>
-          <p:cNvPr id="13" name="TextBox 12"/>
+          <p:cNvPr id="12" name="TextBox 11"/>
           <p:cNvSpPr txBox="1"/>
           <p:nvPr/>
         </p:nvSpPr>
@@ -29384,7 +29196,7 @@
                 <a:ea typeface="IBM Plex Sans Arabic"/>
                 <a:cs typeface="IBM Plex Sans Arabic"/>
               </a:rPr>
-              <a:t>الجلسة 1  ·  ساعة ونصف</a:t>
+              <a:t>الجلسة 1</a:t>
             </a:r>
           </a:p>
         </p:txBody>
@@ -29512,7 +29324,7 @@
                 <a:ea typeface="IBM Plex Sans Arabic"/>
                 <a:cs typeface="IBM Plex Sans Arabic"/>
               </a:rPr>
-              <a:t>الجلسة 2  ·  ساعة</a:t>
+              <a:t>الجلسة 2</a:t>
             </a:r>
           </a:p>
         </p:txBody>
@@ -29640,7 +29452,7 @@
                 <a:ea typeface="IBM Plex Sans Arabic"/>
                 <a:cs typeface="IBM Plex Sans Arabic"/>
               </a:rPr>
-              <a:t>الجلسة 3  ·  ساعة ونصف</a:t>
+              <a:t>الجلسة 3</a:t>
             </a:r>
           </a:p>
         </p:txBody>
@@ -31373,48 +31185,7 @@
       </p:sp>
       <p:sp>
         <p:nvSpPr>
-          <p:cNvPr id="10" name="TextBox 9"/>
-          <p:cNvSpPr txBox="1"/>
-          <p:nvPr/>
-        </p:nvSpPr>
-        <p:spPr>
-          <a:xfrm>
-            <a:off x="548640" y="1591056"/>
-            <a:ext cx="10972800" cy="365760"/>
-          </a:xfrm>
-          <a:prstGeom prst="rect">
-            <a:avLst/>
-          </a:prstGeom>
-          <a:noFill/>
-        </p:spPr>
-        <p:txBody>
-          <a:bodyPr wrap="square" anchor="t">
-            <a:spAutoFit/>
-          </a:bodyPr>
-          <a:lstStyle/>
-          <a:p>
-            <a:pPr algn="r" rtl="1">
-              <a:spcAft>
-                <a:spcPts val="400"/>
-              </a:spcAft>
-            </a:pPr>
-            <a:r>
-              <a:rPr sz="1400" b="0" rtl="1" lang="ar-SA" altLang="en-US">
-                <a:solidFill>
-                  <a:srgbClr val="5A5470"/>
-                </a:solidFill>
-                <a:latin typeface="IBM Plex Sans Arabic"/>
-                <a:ea typeface="IBM Plex Sans Arabic"/>
-                <a:cs typeface="IBM Plex Sans Arabic"/>
-              </a:rPr>
-              <a:t>المدة: ساعة ونصف</a:t>
-            </a:r>
-          </a:p>
-        </p:txBody>
-      </p:sp>
-      <p:sp>
-        <p:nvSpPr>
-          <p:cNvPr id="11" name="Rounded Rectangle 10"/>
+          <p:cNvPr id="10" name="Rounded Rectangle 9"/>
           <p:cNvSpPr/>
           <p:nvPr/>
         </p:nvSpPr>
@@ -31460,7 +31231,7 @@
       </p:sp>
       <p:sp>
         <p:nvSpPr>
-          <p:cNvPr id="12" name="TextBox 11"/>
+          <p:cNvPr id="11" name="TextBox 10"/>
           <p:cNvSpPr txBox="1"/>
           <p:nvPr/>
         </p:nvSpPr>
@@ -31501,7 +31272,7 @@
       </p:sp>
       <p:sp>
         <p:nvSpPr>
-          <p:cNvPr id="13" name="TextBox 12"/>
+          <p:cNvPr id="12" name="TextBox 11"/>
           <p:cNvSpPr txBox="1"/>
           <p:nvPr/>
         </p:nvSpPr>
@@ -36140,7 +35911,7 @@
                 <a:ea typeface="IBM Plex Sans Arabic"/>
                 <a:cs typeface="IBM Plex Sans Arabic"/>
               </a:rPr>
-              <a:t>30 دقيقة — هوية إعلان متكاملة</a:t>
+              <a:t>هوية إعلان متكاملة</a:t>
             </a:r>
           </a:p>
         </p:txBody>
@@ -38290,48 +38061,7 @@
       </p:sp>
       <p:sp>
         <p:nvSpPr>
-          <p:cNvPr id="10" name="TextBox 9"/>
-          <p:cNvSpPr txBox="1"/>
-          <p:nvPr/>
-        </p:nvSpPr>
-        <p:spPr>
-          <a:xfrm>
-            <a:off x="548640" y="1591056"/>
-            <a:ext cx="10972800" cy="365760"/>
-          </a:xfrm>
-          <a:prstGeom prst="rect">
-            <a:avLst/>
-          </a:prstGeom>
-          <a:noFill/>
-        </p:spPr>
-        <p:txBody>
-          <a:bodyPr wrap="square" anchor="t">
-            <a:spAutoFit/>
-          </a:bodyPr>
-          <a:lstStyle/>
-          <a:p>
-            <a:pPr algn="r" rtl="1">
-              <a:spcAft>
-                <a:spcPts val="400"/>
-              </a:spcAft>
-            </a:pPr>
-            <a:r>
-              <a:rPr sz="1400" b="0" rtl="1" lang="ar-SA" altLang="en-US">
-                <a:solidFill>
-                  <a:srgbClr val="5A5470"/>
-                </a:solidFill>
-                <a:latin typeface="IBM Plex Sans Arabic"/>
-                <a:ea typeface="IBM Plex Sans Arabic"/>
-                <a:cs typeface="IBM Plex Sans Arabic"/>
-              </a:rPr>
-              <a:t>المدة: ساعة ونصف</a:t>
-            </a:r>
-          </a:p>
-        </p:txBody>
-      </p:sp>
-      <p:sp>
-        <p:nvSpPr>
-          <p:cNvPr id="11" name="Rounded Rectangle 10"/>
+          <p:cNvPr id="10" name="Rounded Rectangle 9"/>
           <p:cNvSpPr/>
           <p:nvPr/>
         </p:nvSpPr>
@@ -38377,7 +38107,7 @@
       </p:sp>
       <p:sp>
         <p:nvSpPr>
-          <p:cNvPr id="12" name="TextBox 11"/>
+          <p:cNvPr id="11" name="TextBox 10"/>
           <p:cNvSpPr txBox="1"/>
           <p:nvPr/>
         </p:nvSpPr>
@@ -38418,7 +38148,7 @@
       </p:sp>
       <p:sp>
         <p:nvSpPr>
-          <p:cNvPr id="13" name="TextBox 12"/>
+          <p:cNvPr id="12" name="TextBox 11"/>
           <p:cNvSpPr txBox="1"/>
           <p:nvPr/>
         </p:nvSpPr>
@@ -39826,7 +39556,7 @@
                 <a:ea typeface="IBM Plex Sans Arabic"/>
                 <a:cs typeface="IBM Plex Sans Arabic"/>
               </a:rPr>
-              <a:t>الجلسة 1  ·  ساعة ونصف</a:t>
+              <a:t>الجلسة 1</a:t>
             </a:r>
           </a:p>
         </p:txBody>
@@ -39954,7 +39684,7 @@
                 <a:ea typeface="IBM Plex Sans Arabic"/>
                 <a:cs typeface="IBM Plex Sans Arabic"/>
               </a:rPr>
-              <a:t>الجلسة 2  ·  ساعة</a:t>
+              <a:t>الجلسة 2</a:t>
             </a:r>
           </a:p>
         </p:txBody>
@@ -40082,7 +39812,7 @@
                 <a:ea typeface="IBM Plex Sans Arabic"/>
                 <a:cs typeface="IBM Plex Sans Arabic"/>
               </a:rPr>
-              <a:t>الجلسة 3  ·  ساعة ونصف</a:t>
+              <a:t>الجلسة 3</a:t>
             </a:r>
           </a:p>
         </p:txBody>
@@ -40586,48 +40316,7 @@
       </p:sp>
       <p:sp>
         <p:nvSpPr>
-          <p:cNvPr id="10" name="TextBox 9"/>
-          <p:cNvSpPr txBox="1"/>
-          <p:nvPr/>
-        </p:nvSpPr>
-        <p:spPr>
-          <a:xfrm>
-            <a:off x="548640" y="1591056"/>
-            <a:ext cx="10972800" cy="365760"/>
-          </a:xfrm>
-          <a:prstGeom prst="rect">
-            <a:avLst/>
-          </a:prstGeom>
-          <a:noFill/>
-        </p:spPr>
-        <p:txBody>
-          <a:bodyPr wrap="square" anchor="t">
-            <a:spAutoFit/>
-          </a:bodyPr>
-          <a:lstStyle/>
-          <a:p>
-            <a:pPr algn="r" rtl="1">
-              <a:spcAft>
-                <a:spcPts val="400"/>
-              </a:spcAft>
-            </a:pPr>
-            <a:r>
-              <a:rPr sz="1400" b="0" rtl="1" lang="ar-SA" altLang="en-US">
-                <a:solidFill>
-                  <a:srgbClr val="5A5470"/>
-                </a:solidFill>
-                <a:latin typeface="IBM Plex Sans Arabic"/>
-                <a:ea typeface="IBM Plex Sans Arabic"/>
-                <a:cs typeface="IBM Plex Sans Arabic"/>
-              </a:rPr>
-              <a:t>المدة: ساعة ونصف</a:t>
-            </a:r>
-          </a:p>
-        </p:txBody>
-      </p:sp>
-      <p:sp>
-        <p:nvSpPr>
-          <p:cNvPr id="11" name="Rounded Rectangle 10"/>
+          <p:cNvPr id="10" name="Rounded Rectangle 9"/>
           <p:cNvSpPr/>
           <p:nvPr/>
         </p:nvSpPr>
@@ -40673,7 +40362,7 @@
       </p:sp>
       <p:sp>
         <p:nvSpPr>
-          <p:cNvPr id="12" name="TextBox 11"/>
+          <p:cNvPr id="11" name="TextBox 10"/>
           <p:cNvSpPr txBox="1"/>
           <p:nvPr/>
         </p:nvSpPr>
@@ -40714,7 +40403,7 @@
       </p:sp>
       <p:sp>
         <p:nvSpPr>
-          <p:cNvPr id="13" name="TextBox 12"/>
+          <p:cNvPr id="12" name="TextBox 11"/>
           <p:cNvSpPr txBox="1"/>
           <p:nvPr/>
         </p:nvSpPr>
@@ -44277,48 +43966,7 @@
       </p:sp>
       <p:sp>
         <p:nvSpPr>
-          <p:cNvPr id="10" name="TextBox 9"/>
-          <p:cNvSpPr txBox="1"/>
-          <p:nvPr/>
-        </p:nvSpPr>
-        <p:spPr>
-          <a:xfrm>
-            <a:off x="548640" y="1591056"/>
-            <a:ext cx="10972800" cy="365760"/>
-          </a:xfrm>
-          <a:prstGeom prst="rect">
-            <a:avLst/>
-          </a:prstGeom>
-          <a:noFill/>
-        </p:spPr>
-        <p:txBody>
-          <a:bodyPr wrap="square" anchor="t">
-            <a:spAutoFit/>
-          </a:bodyPr>
-          <a:lstStyle/>
-          <a:p>
-            <a:pPr algn="r" rtl="1">
-              <a:spcAft>
-                <a:spcPts val="400"/>
-              </a:spcAft>
-            </a:pPr>
-            <a:r>
-              <a:rPr sz="1400" b="0" rtl="1" lang="ar-SA" altLang="en-US">
-                <a:solidFill>
-                  <a:srgbClr val="5A5470"/>
-                </a:solidFill>
-                <a:latin typeface="IBM Plex Sans Arabic"/>
-                <a:ea typeface="IBM Plex Sans Arabic"/>
-                <a:cs typeface="IBM Plex Sans Arabic"/>
-              </a:rPr>
-              <a:t>المدة: ساعة</a:t>
-            </a:r>
-          </a:p>
-        </p:txBody>
-      </p:sp>
-      <p:sp>
-        <p:nvSpPr>
-          <p:cNvPr id="11" name="Rounded Rectangle 10"/>
+          <p:cNvPr id="10" name="Rounded Rectangle 9"/>
           <p:cNvSpPr/>
           <p:nvPr/>
         </p:nvSpPr>
@@ -44364,7 +44012,7 @@
       </p:sp>
       <p:sp>
         <p:nvSpPr>
-          <p:cNvPr id="12" name="TextBox 11"/>
+          <p:cNvPr id="11" name="TextBox 10"/>
           <p:cNvSpPr txBox="1"/>
           <p:nvPr/>
         </p:nvSpPr>
@@ -44405,7 +44053,7 @@
       </p:sp>
       <p:sp>
         <p:nvSpPr>
-          <p:cNvPr id="13" name="TextBox 12"/>
+          <p:cNvPr id="12" name="TextBox 11"/>
           <p:cNvSpPr txBox="1"/>
           <p:nvPr/>
         </p:nvSpPr>
@@ -48879,48 +48527,7 @@
       </p:sp>
       <p:sp>
         <p:nvSpPr>
-          <p:cNvPr id="10" name="TextBox 9"/>
-          <p:cNvSpPr txBox="1"/>
-          <p:nvPr/>
-        </p:nvSpPr>
-        <p:spPr>
-          <a:xfrm>
-            <a:off x="548640" y="1591056"/>
-            <a:ext cx="10972800" cy="365760"/>
-          </a:xfrm>
-          <a:prstGeom prst="rect">
-            <a:avLst/>
-          </a:prstGeom>
-          <a:noFill/>
-        </p:spPr>
-        <p:txBody>
-          <a:bodyPr wrap="square" anchor="t">
-            <a:spAutoFit/>
-          </a:bodyPr>
-          <a:lstStyle/>
-          <a:p>
-            <a:pPr algn="r" rtl="1">
-              <a:spcAft>
-                <a:spcPts val="400"/>
-              </a:spcAft>
-            </a:pPr>
-            <a:r>
-              <a:rPr sz="1400" b="0" rtl="1" lang="ar-SA" altLang="en-US">
-                <a:solidFill>
-                  <a:srgbClr val="5A5470"/>
-                </a:solidFill>
-                <a:latin typeface="IBM Plex Sans Arabic"/>
-                <a:ea typeface="IBM Plex Sans Arabic"/>
-                <a:cs typeface="IBM Plex Sans Arabic"/>
-              </a:rPr>
-              <a:t>المدة: ساعة ونصف</a:t>
-            </a:r>
-          </a:p>
-        </p:txBody>
-      </p:sp>
-      <p:sp>
-        <p:nvSpPr>
-          <p:cNvPr id="11" name="Rounded Rectangle 10"/>
+          <p:cNvPr id="10" name="Rounded Rectangle 9"/>
           <p:cNvSpPr/>
           <p:nvPr/>
         </p:nvSpPr>
@@ -48966,7 +48573,7 @@
       </p:sp>
       <p:sp>
         <p:nvSpPr>
-          <p:cNvPr id="12" name="TextBox 11"/>
+          <p:cNvPr id="11" name="TextBox 10"/>
           <p:cNvSpPr txBox="1"/>
           <p:nvPr/>
         </p:nvSpPr>
@@ -49007,7 +48614,7 @@
       </p:sp>
       <p:sp>
         <p:nvSpPr>
-          <p:cNvPr id="13" name="TextBox 12"/>
+          <p:cNvPr id="12" name="TextBox 11"/>
           <p:cNvSpPr txBox="1"/>
           <p:nvPr/>
         </p:nvSpPr>
@@ -53731,7 +53338,7 @@
                 <a:ea typeface="IBM Plex Sans Arabic"/>
                 <a:cs typeface="IBM Plex Sans Arabic"/>
               </a:rPr>
-              <a:t>45 دقيقة — فرق مصغرة وحل متكامل</a:t>
+              <a:t>فرق مصغرة وحل متكامل</a:t>
             </a:r>
           </a:p>
         </p:txBody>

</xml_diff>

<commit_message>
feat: update workshop assets by replacing outdated icons, enhancing photo fetching script for improved logo sourcing, and refining tool icon mapping for better accuracy in presentations
</commit_message>
<xml_diff>
--- a/web-presentation/pdf-exports/ETRA-AI-Tools-Workshop-3Days-AR.pptx
+++ b/web-presentation/pdf-exports/ETRA-AI-Tools-Workshop-3Days-AR.pptx
@@ -4504,7 +4504,7 @@
       </p:sp>
       <p:pic>
         <p:nvPicPr>
-          <p:cNvPr id="23" name="Picture 22" descr="icon-google.png"/>
+          <p:cNvPr id="23" name="Picture 22" descr="icon-gemini.png"/>
           <p:cNvPicPr>
             <a:picLocks noChangeAspect="1"/>
           </p:cNvPicPr>
@@ -14943,7 +14943,7 @@
       </p:sp>
       <p:pic>
         <p:nvPicPr>
-          <p:cNvPr id="17" name="Picture 16" descr="icon-anthropic.png"/>
+          <p:cNvPr id="17" name="Picture 16" descr="icon-chatpdf.png"/>
           <p:cNvPicPr>
             <a:picLocks noChangeAspect="1"/>
           </p:cNvPicPr>
@@ -26482,15 +26482,39 @@
           </a:p>
         </p:txBody>
       </p:sp>
-      <p:sp>
-        <p:nvSpPr>
-          <p:cNvPr id="22" name="TextBox 21"/>
-          <p:cNvSpPr txBox="1"/>
-          <p:nvPr/>
-        </p:nvSpPr>
-        <p:spPr>
-          <a:xfrm>
-            <a:off x="777240" y="2606040"/>
+      <p:pic>
+        <p:nvPicPr>
+          <p:cNvPr id="22" name="Picture 21" descr="icon-leonardo.png"/>
+          <p:cNvPicPr>
+            <a:picLocks noChangeAspect="1"/>
+          </p:cNvPicPr>
+          <p:nvPr/>
+        </p:nvPicPr>
+        <p:blipFill>
+          <a:blip r:embed="rId5"/>
+          <a:stretch>
+            <a:fillRect/>
+          </a:stretch>
+        </p:blipFill>
+        <p:spPr>
+          <a:xfrm>
+            <a:off x="2060448" y="2468880"/>
+            <a:ext cx="502920" cy="502920"/>
+          </a:xfrm>
+          <a:prstGeom prst="rect">
+            <a:avLst/>
+          </a:prstGeom>
+        </p:spPr>
+      </p:pic>
+      <p:sp>
+        <p:nvSpPr>
+          <p:cNvPr id="23" name="TextBox 22"/>
+          <p:cNvSpPr txBox="1"/>
+          <p:nvPr/>
+        </p:nvSpPr>
+        <p:spPr>
+          <a:xfrm>
+            <a:off x="777240" y="3108960"/>
             <a:ext cx="3078480" cy="640080"/>
           </a:xfrm>
           <a:prstGeom prst="rect">
@@ -26525,7 +26549,7 @@
       </p:sp>
       <p:sp>
         <p:nvSpPr>
-          <p:cNvPr id="23" name="TextBox 22"/>
+          <p:cNvPr id="24" name="TextBox 23"/>
           <p:cNvSpPr txBox="1"/>
           <p:nvPr/>
         </p:nvSpPr>
@@ -31713,7 +31737,7 @@
       </p:sp>
       <p:pic>
         <p:nvPicPr>
-          <p:cNvPr id="12" name="Picture 11" descr="icon-canva.png"/>
+          <p:cNvPr id="12" name="Picture 11" descr="icon-gamma.png"/>
           <p:cNvPicPr>
             <a:picLocks noChangeAspect="1"/>
           </p:cNvPicPr>
@@ -31909,14 +31933,14 @@
       </p:sp>
       <p:pic>
         <p:nvPicPr>
-          <p:cNvPr id="17" name="Picture 16" descr="icon-canva.png"/>
+          <p:cNvPr id="17" name="Picture 16" descr="icon-beautifulai.png"/>
           <p:cNvPicPr>
             <a:picLocks noChangeAspect="1"/>
           </p:cNvPicPr>
           <p:nvPr/>
         </p:nvPicPr>
         <p:blipFill>
-          <a:blip r:embed="rId3"/>
+          <a:blip r:embed="rId4"/>
           <a:stretch>
             <a:fillRect/>
           </a:stretch>
@@ -34820,7 +34844,7 @@
       </p:sp>
       <p:pic>
         <p:nvPicPr>
-          <p:cNvPr id="12" name="Picture 11" descr="icon-zapier.png"/>
+          <p:cNvPr id="12" name="Picture 11" descr="icon-heygen.png"/>
           <p:cNvPicPr>
             <a:picLocks noChangeAspect="1"/>
           </p:cNvPicPr>
@@ -35014,15 +35038,39 @@
           </a:p>
         </p:txBody>
       </p:sp>
-      <p:sp>
-        <p:nvSpPr>
-          <p:cNvPr id="17" name="TextBox 16"/>
-          <p:cNvSpPr txBox="1"/>
-          <p:nvPr/>
-        </p:nvSpPr>
-        <p:spPr>
-          <a:xfrm>
-            <a:off x="4541520" y="2606040"/>
+      <p:pic>
+        <p:nvPicPr>
+          <p:cNvPr id="17" name="Picture 16" descr="icon-elevenlabs.png"/>
+          <p:cNvPicPr>
+            <a:picLocks noChangeAspect="1"/>
+          </p:cNvPicPr>
+          <p:nvPr/>
+        </p:nvPicPr>
+        <p:blipFill>
+          <a:blip r:embed="rId4"/>
+          <a:stretch>
+            <a:fillRect/>
+          </a:stretch>
+        </p:blipFill>
+        <p:spPr>
+          <a:xfrm>
+            <a:off x="5824728" y="2468880"/>
+            <a:ext cx="502920" cy="502920"/>
+          </a:xfrm>
+          <a:prstGeom prst="rect">
+            <a:avLst/>
+          </a:prstGeom>
+        </p:spPr>
+      </p:pic>
+      <p:sp>
+        <p:nvSpPr>
+          <p:cNvPr id="18" name="TextBox 17"/>
+          <p:cNvSpPr txBox="1"/>
+          <p:nvPr/>
+        </p:nvSpPr>
+        <p:spPr>
+          <a:xfrm>
+            <a:off x="4541520" y="3108960"/>
             <a:ext cx="3078480" cy="640080"/>
           </a:xfrm>
           <a:prstGeom prst="rect">
@@ -35057,7 +35105,7 @@
       </p:sp>
       <p:sp>
         <p:nvSpPr>
-          <p:cNvPr id="18" name="TextBox 17"/>
+          <p:cNvPr id="19" name="TextBox 18"/>
           <p:cNvSpPr txBox="1"/>
           <p:nvPr/>
         </p:nvSpPr>
@@ -35098,7 +35146,7 @@
       </p:sp>
       <p:sp>
         <p:nvSpPr>
-          <p:cNvPr id="19" name="Rounded Rectangle 18"/>
+          <p:cNvPr id="20" name="Rounded Rectangle 19"/>
           <p:cNvSpPr/>
           <p:nvPr/>
         </p:nvSpPr>
@@ -35144,7 +35192,7 @@
       </p:sp>
       <p:sp>
         <p:nvSpPr>
-          <p:cNvPr id="20" name="Rectangle 19"/>
+          <p:cNvPr id="21" name="Rectangle 20"/>
           <p:cNvSpPr/>
           <p:nvPr/>
         </p:nvSpPr>
@@ -35186,15 +35234,39 @@
           </a:p>
         </p:txBody>
       </p:sp>
-      <p:sp>
-        <p:nvSpPr>
-          <p:cNvPr id="21" name="TextBox 20"/>
-          <p:cNvSpPr txBox="1"/>
-          <p:nvPr/>
-        </p:nvSpPr>
-        <p:spPr>
-          <a:xfrm>
-            <a:off x="777240" y="2606040"/>
+      <p:pic>
+        <p:nvPicPr>
+          <p:cNvPr id="22" name="Picture 21" descr="icon-runway.png"/>
+          <p:cNvPicPr>
+            <a:picLocks noChangeAspect="1"/>
+          </p:cNvPicPr>
+          <p:nvPr/>
+        </p:nvPicPr>
+        <p:blipFill>
+          <a:blip r:embed="rId5"/>
+          <a:stretch>
+            <a:fillRect/>
+          </a:stretch>
+        </p:blipFill>
+        <p:spPr>
+          <a:xfrm>
+            <a:off x="2060448" y="2468880"/>
+            <a:ext cx="502920" cy="502920"/>
+          </a:xfrm>
+          <a:prstGeom prst="rect">
+            <a:avLst/>
+          </a:prstGeom>
+        </p:spPr>
+      </p:pic>
+      <p:sp>
+        <p:nvSpPr>
+          <p:cNvPr id="23" name="TextBox 22"/>
+          <p:cNvSpPr txBox="1"/>
+          <p:nvPr/>
+        </p:nvSpPr>
+        <p:spPr>
+          <a:xfrm>
+            <a:off x="777240" y="3108960"/>
             <a:ext cx="3078480" cy="640080"/>
           </a:xfrm>
           <a:prstGeom prst="rect">
@@ -35229,7 +35301,7 @@
       </p:sp>
       <p:sp>
         <p:nvSpPr>
-          <p:cNvPr id="22" name="TextBox 21"/>
+          <p:cNvPr id="24" name="TextBox 23"/>
           <p:cNvSpPr txBox="1"/>
           <p:nvPr/>
         </p:nvSpPr>
@@ -45789,15 +45861,39 @@
           </a:p>
         </p:txBody>
       </p:sp>
-      <p:sp>
-        <p:nvSpPr>
-          <p:cNvPr id="12" name="TextBox 11"/>
-          <p:cNvSpPr txBox="1"/>
-          <p:nvPr/>
-        </p:nvSpPr>
-        <p:spPr>
-          <a:xfrm>
-            <a:off x="777240" y="2606040"/>
+      <p:pic>
+        <p:nvPicPr>
+          <p:cNvPr id="12" name="Picture 11" descr="icon-openai.png"/>
+          <p:cNvPicPr>
+            <a:picLocks noChangeAspect="1"/>
+          </p:cNvPicPr>
+          <p:nvPr/>
+        </p:nvPicPr>
+        <p:blipFill>
+          <a:blip r:embed="rId3"/>
+          <a:stretch>
+            <a:fillRect/>
+          </a:stretch>
+        </p:blipFill>
+        <p:spPr>
+          <a:xfrm>
+            <a:off x="5824728" y="2468880"/>
+            <a:ext cx="502920" cy="502920"/>
+          </a:xfrm>
+          <a:prstGeom prst="rect">
+            <a:avLst/>
+          </a:prstGeom>
+        </p:spPr>
+      </p:pic>
+      <p:sp>
+        <p:nvSpPr>
+          <p:cNvPr id="13" name="TextBox 12"/>
+          <p:cNvSpPr txBox="1"/>
+          <p:nvPr/>
+        </p:nvSpPr>
+        <p:spPr>
+          <a:xfrm>
+            <a:off x="777240" y="3108960"/>
             <a:ext cx="10607040" cy="640080"/>
           </a:xfrm>
           <a:prstGeom prst="rect">
@@ -45832,7 +45928,7 @@
       </p:sp>
       <p:sp>
         <p:nvSpPr>
-          <p:cNvPr id="13" name="TextBox 12"/>
+          <p:cNvPr id="14" name="TextBox 13"/>
           <p:cNvSpPr txBox="1"/>
           <p:nvPr/>
         </p:nvSpPr>
@@ -50460,14 +50556,14 @@
       </p:sp>
       <p:pic>
         <p:nvPicPr>
-          <p:cNvPr id="17" name="Picture 16" descr="icon-zapier.png"/>
+          <p:cNvPr id="17" name="Picture 16" descr="icon-make.png"/>
           <p:cNvPicPr>
             <a:picLocks noChangeAspect="1"/>
           </p:cNvPicPr>
           <p:nvPr/>
         </p:nvPicPr>
         <p:blipFill>
-          <a:blip r:embed="rId3"/>
+          <a:blip r:embed="rId4"/>
           <a:stretch>
             <a:fillRect/>
           </a:stretch>
@@ -56923,15 +57019,39 @@
           </a:p>
         </p:txBody>
       </p:sp>
-      <p:sp>
-        <p:nvSpPr>
-          <p:cNvPr id="17" name="TextBox 16"/>
-          <p:cNvSpPr txBox="1"/>
-          <p:nvPr/>
-        </p:nvSpPr>
-        <p:spPr>
-          <a:xfrm>
-            <a:off x="777240" y="2606040"/>
+      <p:pic>
+        <p:nvPicPr>
+          <p:cNvPr id="17" name="Picture 16" descr="icon-poe.png"/>
+          <p:cNvPicPr>
+            <a:picLocks noChangeAspect="1"/>
+          </p:cNvPicPr>
+          <p:nvPr/>
+        </p:nvPicPr>
+        <p:blipFill>
+          <a:blip r:embed="rId4"/>
+          <a:stretch>
+            <a:fillRect/>
+          </a:stretch>
+        </p:blipFill>
+        <p:spPr>
+          <a:xfrm>
+            <a:off x="3001518" y="2468880"/>
+            <a:ext cx="502920" cy="502920"/>
+          </a:xfrm>
+          <a:prstGeom prst="rect">
+            <a:avLst/>
+          </a:prstGeom>
+        </p:spPr>
+      </p:pic>
+      <p:sp>
+        <p:nvSpPr>
+          <p:cNvPr id="18" name="TextBox 17"/>
+          <p:cNvSpPr txBox="1"/>
+          <p:nvPr/>
+        </p:nvSpPr>
+        <p:spPr>
+          <a:xfrm>
+            <a:off x="777240" y="3108960"/>
             <a:ext cx="4960620" cy="640080"/>
           </a:xfrm>
           <a:prstGeom prst="rect">
@@ -56966,7 +57086,7 @@
       </p:sp>
       <p:sp>
         <p:nvSpPr>
-          <p:cNvPr id="18" name="TextBox 17"/>
+          <p:cNvPr id="19" name="TextBox 18"/>
           <p:cNvSpPr txBox="1"/>
           <p:nvPr/>
         </p:nvSpPr>
@@ -64927,7 +65047,7 @@
       </p:sp>
       <p:pic>
         <p:nvPicPr>
-          <p:cNvPr id="23" name="Picture 22" descr="icon-zapier.png"/>
+          <p:cNvPr id="23" name="Picture 22" descr="icon-heygen.png"/>
           <p:cNvPicPr>
             <a:picLocks noChangeAspect="1"/>
           </p:cNvPicPr>

</xml_diff>

<commit_message>
feat: enhance PowerPoint generation script by adding image handling improvements, including better picture fitting and logo embedding with rounded backgrounds, while updating workshop content with new photos for a more engaging presentation
</commit_message>
<xml_diff>
--- a/web-presentation/pdf-exports/ETRA-AI-Tools-Workshop-3Days-AR.pptx
+++ b/web-presentation/pdf-exports/ETRA-AI-Tools-Workshop-3Days-AR.pptx
@@ -3485,7 +3485,7 @@
       </p:sp>
       <p:pic>
         <p:nvPicPr>
-          <p:cNvPr id="9" name="Picture 8" descr="hero-cover.jpg"/>
+          <p:cNvPr id="9" name="Picture 8" descr=".crop-hero-cover.jpg"/>
           <p:cNvPicPr>
             <a:picLocks noChangeAspect="1"/>
           </p:cNvPicPr>
@@ -3499,8 +3499,8 @@
         </p:blipFill>
         <p:spPr>
           <a:xfrm>
-            <a:off x="652179340800" y="1719072"/>
-            <a:ext cx="3977639" cy="2237421"/>
+            <a:off x="713232" y="1719072"/>
+            <a:ext cx="3977639" cy="3794760"/>
           </a:xfrm>
           <a:prstGeom prst="rect">
             <a:avLst/>
@@ -4112,7 +4112,7 @@
       </p:sp>
       <p:pic>
         <p:nvPicPr>
-          <p:cNvPr id="13" name="Picture 12" descr="icon-openai.png"/>
+          <p:cNvPr id="13" name="Picture 12" descr=".pad-icon-openai.png"/>
           <p:cNvPicPr>
             <a:picLocks noChangeAspect="1"/>
           </p:cNvPicPr>
@@ -4308,7 +4308,7 @@
       </p:sp>
       <p:pic>
         <p:nvPicPr>
-          <p:cNvPr id="18" name="Picture 17" descr="icon-anthropic.png"/>
+          <p:cNvPr id="18" name="Picture 17" descr=".pad-icon-anthropic.png"/>
           <p:cNvPicPr>
             <a:picLocks noChangeAspect="1"/>
           </p:cNvPicPr>
@@ -4504,7 +4504,7 @@
       </p:sp>
       <p:pic>
         <p:nvPicPr>
-          <p:cNvPr id="23" name="Picture 22" descr="icon-gemini.png"/>
+          <p:cNvPr id="23" name="Picture 22" descr=".pad-icon-gemini.png"/>
           <p:cNvPicPr>
             <a:picLocks noChangeAspect="1"/>
           </p:cNvPicPr>
@@ -6055,7 +6055,7 @@
         </p:blipFill>
         <p:spPr>
           <a:xfrm>
-            <a:off x="548640" y="1856202739200"/>
+            <a:off x="548640" y="2504052"/>
             <a:ext cx="5212080" cy="3075191"/>
           </a:xfrm>
           <a:prstGeom prst="rect">
@@ -9597,7 +9597,7 @@
         <p:spPr>
           <a:xfrm>
             <a:off x="548640" y="1024128"/>
-            <a:ext cx="10972800" cy="640080"/>
+            <a:ext cx="6400800" cy="640080"/>
           </a:xfrm>
           <a:prstGeom prst="rect">
             <a:avLst/>
@@ -9637,8 +9637,8 @@
         </p:nvSpPr>
         <p:spPr>
           <a:xfrm>
-            <a:off x="548640" y="2286000"/>
-            <a:ext cx="11064240" cy="3200400"/>
+            <a:off x="5349240" y="2148840"/>
+            <a:ext cx="6217920" cy="3566160"/>
           </a:xfrm>
           <a:prstGeom prst="roundRect">
             <a:avLst>
@@ -9683,8 +9683,8 @@
         </p:nvSpPr>
         <p:spPr>
           <a:xfrm>
-            <a:off x="914400" y="2560320"/>
-            <a:ext cx="10332720" cy="365760"/>
+            <a:off x="5623560" y="2377440"/>
+            <a:ext cx="5669280" cy="365760"/>
           </a:xfrm>
           <a:prstGeom prst="rect">
             <a:avLst/>
@@ -9724,8 +9724,8 @@
         </p:nvSpPr>
         <p:spPr>
           <a:xfrm>
-            <a:off x="914400" y="3108960"/>
-            <a:ext cx="10332720" cy="1828800"/>
+            <a:off x="5623560" y="2880360"/>
+            <a:ext cx="5669280" cy="2377440"/>
           </a:xfrm>
           <a:prstGeom prst="rect">
             <a:avLst/>
@@ -9744,7 +9744,7 @@
               </a:spcAft>
             </a:pPr>
             <a:r>
-              <a:rPr sz="2000" b="0" rtl="1" lang="ar-SA" altLang="en-US">
+              <a:rPr sz="1800" b="0" rtl="1" lang="ar-SA" altLang="en-US">
                 <a:solidFill>
                   <a:srgbClr val="121018"/>
                 </a:solidFill>
@@ -9757,6 +9757,76 @@
           </a:p>
         </p:txBody>
       </p:sp>
+      <p:sp>
+        <p:nvSpPr>
+          <p:cNvPr id="13" name="Rounded Rectangle 12"/>
+          <p:cNvSpPr/>
+          <p:nvPr/>
+        </p:nvSpPr>
+        <p:spPr>
+          <a:xfrm>
+            <a:off x="548640" y="2148840"/>
+            <a:ext cx="4480560" cy="3566160"/>
+          </a:xfrm>
+          <a:prstGeom prst="roundRect">
+            <a:avLst>
+              <a:gd name="adj" fmla="val 10000"/>
+            </a:avLst>
+          </a:prstGeom>
+          <a:solidFill>
+            <a:srgbClr val="F5F1FC"/>
+          </a:solidFill>
+          <a:ln>
+            <a:noFill/>
+          </a:ln>
+          <a:effectLst/>
+        </p:spPr>
+        <p:style>
+          <a:lnRef idx="1">
+            <a:schemeClr val="accent1"/>
+          </a:lnRef>
+          <a:fillRef idx="3">
+            <a:schemeClr val="accent1"/>
+          </a:fillRef>
+          <a:effectRef idx="2">
+            <a:schemeClr val="accent1"/>
+          </a:effectRef>
+          <a:fontRef idx="minor">
+            <a:schemeClr val="lt1"/>
+          </a:fontRef>
+        </p:style>
+        <p:txBody>
+          <a:bodyPr rtlCol="0" anchor="ctr"/>
+          <a:lstStyle/>
+          <a:p>
+            <a:pPr algn="ctr"/>
+          </a:p>
+        </p:txBody>
+      </p:sp>
+      <p:pic>
+        <p:nvPicPr>
+          <p:cNvPr id="14" name="Picture 13" descr=".crop-hero-day1.jpg"/>
+          <p:cNvPicPr>
+            <a:picLocks noChangeAspect="1"/>
+          </p:cNvPicPr>
+          <p:nvPr/>
+        </p:nvPicPr>
+        <p:blipFill>
+          <a:blip r:embed="rId3"/>
+          <a:stretch>
+            <a:fillRect/>
+          </a:stretch>
+        </p:blipFill>
+        <p:spPr>
+          <a:xfrm>
+            <a:off x="713232" y="2331720"/>
+            <a:ext cx="4160520" cy="3200400"/>
+          </a:xfrm>
+          <a:prstGeom prst="rect">
+            <a:avLst/>
+          </a:prstGeom>
+        </p:spPr>
+      </p:pic>
     </p:spTree>
   </p:cSld>
   <p:clrMapOvr>
@@ -13107,7 +13177,7 @@
         <p:spPr>
           <a:xfrm>
             <a:off x="548640" y="1024128"/>
-            <a:ext cx="10972800" cy="640080"/>
+            <a:ext cx="6400800" cy="640080"/>
           </a:xfrm>
           <a:prstGeom prst="rect">
             <a:avLst/>
@@ -13147,8 +13217,8 @@
         </p:nvSpPr>
         <p:spPr>
           <a:xfrm>
-            <a:off x="548640" y="2286000"/>
-            <a:ext cx="11064240" cy="3200400"/>
+            <a:off x="5349240" y="2148840"/>
+            <a:ext cx="6217920" cy="3566160"/>
           </a:xfrm>
           <a:prstGeom prst="roundRect">
             <a:avLst>
@@ -13193,8 +13263,8 @@
         </p:nvSpPr>
         <p:spPr>
           <a:xfrm>
-            <a:off x="914400" y="2560320"/>
-            <a:ext cx="10332720" cy="365760"/>
+            <a:off x="5623560" y="2377440"/>
+            <a:ext cx="5669280" cy="365760"/>
           </a:xfrm>
           <a:prstGeom prst="rect">
             <a:avLst/>
@@ -13234,8 +13304,8 @@
         </p:nvSpPr>
         <p:spPr>
           <a:xfrm>
-            <a:off x="914400" y="3108960"/>
-            <a:ext cx="10332720" cy="1828800"/>
+            <a:off x="5623560" y="2880360"/>
+            <a:ext cx="5669280" cy="2377440"/>
           </a:xfrm>
           <a:prstGeom prst="rect">
             <a:avLst/>
@@ -13254,7 +13324,7 @@
               </a:spcAft>
             </a:pPr>
             <a:r>
-              <a:rPr sz="2000" b="0" rtl="1" lang="ar-SA" altLang="en-US">
+              <a:rPr sz="1800" b="0" rtl="1" lang="ar-SA" altLang="en-US">
                 <a:solidFill>
                   <a:srgbClr val="121018"/>
                 </a:solidFill>
@@ -13267,6 +13337,76 @@
           </a:p>
         </p:txBody>
       </p:sp>
+      <p:sp>
+        <p:nvSpPr>
+          <p:cNvPr id="13" name="Rounded Rectangle 12"/>
+          <p:cNvSpPr/>
+          <p:nvPr/>
+        </p:nvSpPr>
+        <p:spPr>
+          <a:xfrm>
+            <a:off x="548640" y="2148840"/>
+            <a:ext cx="4480560" cy="3566160"/>
+          </a:xfrm>
+          <a:prstGeom prst="roundRect">
+            <a:avLst>
+              <a:gd name="adj" fmla="val 10000"/>
+            </a:avLst>
+          </a:prstGeom>
+          <a:solidFill>
+            <a:srgbClr val="F5F1FC"/>
+          </a:solidFill>
+          <a:ln>
+            <a:noFill/>
+          </a:ln>
+          <a:effectLst/>
+        </p:spPr>
+        <p:style>
+          <a:lnRef idx="1">
+            <a:schemeClr val="accent1"/>
+          </a:lnRef>
+          <a:fillRef idx="3">
+            <a:schemeClr val="accent1"/>
+          </a:fillRef>
+          <a:effectRef idx="2">
+            <a:schemeClr val="accent1"/>
+          </a:effectRef>
+          <a:fontRef idx="minor">
+            <a:schemeClr val="lt1"/>
+          </a:fontRef>
+        </p:style>
+        <p:txBody>
+          <a:bodyPr rtlCol="0" anchor="ctr"/>
+          <a:lstStyle/>
+          <a:p>
+            <a:pPr algn="ctr"/>
+          </a:p>
+        </p:txBody>
+      </p:sp>
+      <p:pic>
+        <p:nvPicPr>
+          <p:cNvPr id="14" name="Picture 13" descr=".crop-hero-research.jpg"/>
+          <p:cNvPicPr>
+            <a:picLocks noChangeAspect="1"/>
+          </p:cNvPicPr>
+          <p:nvPr/>
+        </p:nvPicPr>
+        <p:blipFill>
+          <a:blip r:embed="rId3"/>
+          <a:stretch>
+            <a:fillRect/>
+          </a:stretch>
+        </p:blipFill>
+        <p:spPr>
+          <a:xfrm>
+            <a:off x="713232" y="2331720"/>
+            <a:ext cx="4160520" cy="3200400"/>
+          </a:xfrm>
+          <a:prstGeom prst="rect">
+            <a:avLst/>
+          </a:prstGeom>
+        </p:spPr>
+      </p:pic>
     </p:spTree>
   </p:cSld>
   <p:clrMapOvr>
@@ -14747,7 +14887,7 @@
       </p:sp>
       <p:pic>
         <p:nvPicPr>
-          <p:cNvPr id="12" name="Picture 11" descr="icon-perplexity.png"/>
+          <p:cNvPr id="12" name="Picture 11" descr=".pad-icon-perplexity.png"/>
           <p:cNvPicPr>
             <a:picLocks noChangeAspect="1"/>
           </p:cNvPicPr>
@@ -14943,7 +15083,7 @@
       </p:sp>
       <p:pic>
         <p:nvPicPr>
-          <p:cNvPr id="17" name="Picture 16" descr="icon-chatpdf.png"/>
+          <p:cNvPr id="17" name="Picture 16" descr=".pad-icon-chatpdf.png"/>
           <p:cNvPicPr>
             <a:picLocks noChangeAspect="1"/>
           </p:cNvPicPr>
@@ -22395,7 +22535,7 @@
       </p:sp>
       <p:pic>
         <p:nvPicPr>
-          <p:cNvPr id="7" name="Picture 6" descr="hero-day2.jpg"/>
+          <p:cNvPr id="7" name="Picture 6" descr=".crop-hero-day2.jpg"/>
           <p:cNvPicPr>
             <a:picLocks noChangeAspect="1"/>
           </p:cNvPicPr>
@@ -22409,8 +22549,8 @@
         </p:blipFill>
         <p:spPr>
           <a:xfrm>
-            <a:off x="627096736152" y="1371600"/>
-            <a:ext cx="1499615" cy="1874519"/>
+            <a:off x="685800" y="1371600"/>
+            <a:ext cx="3931920" cy="1874519"/>
           </a:xfrm>
           <a:prstGeom prst="rect">
             <a:avLst/>
@@ -23860,7 +24000,7 @@
       </p:sp>
       <p:pic>
         <p:nvPicPr>
-          <p:cNvPr id="14" name="Picture 13" descr="hero-media.jpg"/>
+          <p:cNvPr id="14" name="Picture 13" descr=".crop-hero-media.jpg"/>
           <p:cNvPicPr>
             <a:picLocks noChangeAspect="1"/>
           </p:cNvPicPr>
@@ -23874,8 +24014,8 @@
         </p:blipFill>
         <p:spPr>
           <a:xfrm>
-            <a:off x="652179340800" y="2331720"/>
-            <a:ext cx="4160520" cy="2772689"/>
+            <a:off x="713232" y="2331720"/>
+            <a:ext cx="4160520" cy="3200400"/>
           </a:xfrm>
           <a:prstGeom prst="rect">
             <a:avLst/>
@@ -26092,7 +26232,7 @@
       </p:sp>
       <p:pic>
         <p:nvPicPr>
-          <p:cNvPr id="12" name="Picture 11" descr="icon-midjourney.png"/>
+          <p:cNvPr id="12" name="Picture 11" descr=".pad-icon-midjourney.png"/>
           <p:cNvPicPr>
             <a:picLocks noChangeAspect="1"/>
           </p:cNvPicPr>
@@ -26288,7 +26428,7 @@
       </p:sp>
       <p:pic>
         <p:nvPicPr>
-          <p:cNvPr id="17" name="Picture 16" descr="icon-openai.png"/>
+          <p:cNvPr id="17" name="Picture 16" descr=".pad-icon-openai.png"/>
           <p:cNvPicPr>
             <a:picLocks noChangeAspect="1"/>
           </p:cNvPicPr>
@@ -26484,7 +26624,7 @@
       </p:sp>
       <p:pic>
         <p:nvPicPr>
-          <p:cNvPr id="22" name="Picture 21" descr="icon-leonardo.png"/>
+          <p:cNvPr id="22" name="Picture 21" descr=".pad-icon-leonardo.png"/>
           <p:cNvPicPr>
             <a:picLocks noChangeAspect="1"/>
           </p:cNvPicPr>
@@ -29251,7 +29391,7 @@
       </p:sp>
       <p:pic>
         <p:nvPicPr>
-          <p:cNvPr id="7" name="Picture 6" descr="hero-day1.jpg"/>
+          <p:cNvPr id="7" name="Picture 6" descr=".crop-hero-day1.jpg"/>
           <p:cNvPicPr>
             <a:picLocks noChangeAspect="1"/>
           </p:cNvPicPr>
@@ -29265,8 +29405,8 @@
         </p:blipFill>
         <p:spPr>
           <a:xfrm>
-            <a:off x="627096237469" y="1371600"/>
-            <a:ext cx="2496980" cy="1874519"/>
+            <a:off x="685800" y="1371600"/>
+            <a:ext cx="3931920" cy="1874519"/>
           </a:xfrm>
           <a:prstGeom prst="rect">
             <a:avLst/>
@@ -30097,7 +30237,7 @@
         <p:spPr>
           <a:xfrm>
             <a:off x="548640" y="1024128"/>
-            <a:ext cx="10972800" cy="640080"/>
+            <a:ext cx="6400800" cy="640080"/>
           </a:xfrm>
           <a:prstGeom prst="rect">
             <a:avLst/>
@@ -30137,8 +30277,8 @@
         </p:nvSpPr>
         <p:spPr>
           <a:xfrm>
-            <a:off x="548640" y="2286000"/>
-            <a:ext cx="11064240" cy="3200400"/>
+            <a:off x="5349240" y="2148840"/>
+            <a:ext cx="6217920" cy="3566160"/>
           </a:xfrm>
           <a:prstGeom prst="roundRect">
             <a:avLst>
@@ -30183,8 +30323,8 @@
         </p:nvSpPr>
         <p:spPr>
           <a:xfrm>
-            <a:off x="914400" y="2560320"/>
-            <a:ext cx="10332720" cy="365760"/>
+            <a:off x="5623560" y="2377440"/>
+            <a:ext cx="5669280" cy="365760"/>
           </a:xfrm>
           <a:prstGeom prst="rect">
             <a:avLst/>
@@ -30224,8 +30364,8 @@
         </p:nvSpPr>
         <p:spPr>
           <a:xfrm>
-            <a:off x="914400" y="3108960"/>
-            <a:ext cx="10332720" cy="1828800"/>
+            <a:off x="5623560" y="2880360"/>
+            <a:ext cx="5669280" cy="2377440"/>
           </a:xfrm>
           <a:prstGeom prst="rect">
             <a:avLst/>
@@ -30244,7 +30384,7 @@
               </a:spcAft>
             </a:pPr>
             <a:r>
-              <a:rPr sz="2000" b="0" rtl="1" lang="ar-SA" altLang="en-US">
+              <a:rPr sz="1800" b="0" rtl="1" lang="ar-SA" altLang="en-US">
                 <a:solidFill>
                   <a:srgbClr val="121018"/>
                 </a:solidFill>
@@ -30257,6 +30397,76 @@
           </a:p>
         </p:txBody>
       </p:sp>
+      <p:sp>
+        <p:nvSpPr>
+          <p:cNvPr id="13" name="Rounded Rectangle 12"/>
+          <p:cNvSpPr/>
+          <p:nvPr/>
+        </p:nvSpPr>
+        <p:spPr>
+          <a:xfrm>
+            <a:off x="548640" y="2148840"/>
+            <a:ext cx="4480560" cy="3566160"/>
+          </a:xfrm>
+          <a:prstGeom prst="roundRect">
+            <a:avLst>
+              <a:gd name="adj" fmla="val 10000"/>
+            </a:avLst>
+          </a:prstGeom>
+          <a:solidFill>
+            <a:srgbClr val="F5F1FC"/>
+          </a:solidFill>
+          <a:ln>
+            <a:noFill/>
+          </a:ln>
+          <a:effectLst/>
+        </p:spPr>
+        <p:style>
+          <a:lnRef idx="1">
+            <a:schemeClr val="accent1"/>
+          </a:lnRef>
+          <a:fillRef idx="3">
+            <a:schemeClr val="accent1"/>
+          </a:fillRef>
+          <a:effectRef idx="2">
+            <a:schemeClr val="accent1"/>
+          </a:effectRef>
+          <a:fontRef idx="minor">
+            <a:schemeClr val="lt1"/>
+          </a:fontRef>
+        </p:style>
+        <p:txBody>
+          <a:bodyPr rtlCol="0" anchor="ctr"/>
+          <a:lstStyle/>
+          <a:p>
+            <a:pPr algn="ctr"/>
+          </a:p>
+        </p:txBody>
+      </p:sp>
+      <p:pic>
+        <p:nvPicPr>
+          <p:cNvPr id="14" name="Picture 13" descr=".crop-hero-day2.jpg"/>
+          <p:cNvPicPr>
+            <a:picLocks noChangeAspect="1"/>
+          </p:cNvPicPr>
+          <p:nvPr/>
+        </p:nvPicPr>
+        <p:blipFill>
+          <a:blip r:embed="rId3"/>
+          <a:stretch>
+            <a:fillRect/>
+          </a:stretch>
+        </p:blipFill>
+        <p:spPr>
+          <a:xfrm>
+            <a:off x="713232" y="2331720"/>
+            <a:ext cx="4160520" cy="3200400"/>
+          </a:xfrm>
+          <a:prstGeom prst="rect">
+            <a:avLst/>
+          </a:prstGeom>
+        </p:spPr>
+      </p:pic>
     </p:spTree>
   </p:cSld>
   <p:clrMapOvr>
@@ -31737,7 +31947,7 @@
       </p:sp>
       <p:pic>
         <p:nvPicPr>
-          <p:cNvPr id="12" name="Picture 11" descr="icon-gamma.png"/>
+          <p:cNvPr id="12" name="Picture 11" descr=".pad-icon-gamma.png"/>
           <p:cNvPicPr>
             <a:picLocks noChangeAspect="1"/>
           </p:cNvPicPr>
@@ -31933,7 +32143,7 @@
       </p:sp>
       <p:pic>
         <p:nvPicPr>
-          <p:cNvPr id="17" name="Picture 16" descr="icon-beautifulai.png"/>
+          <p:cNvPr id="17" name="Picture 16" descr=".pad-icon-beautifulai.png"/>
           <p:cNvPicPr>
             <a:picLocks noChangeAspect="1"/>
           </p:cNvPicPr>
@@ -33516,7 +33726,7 @@
         <p:spPr>
           <a:xfrm>
             <a:off x="548640" y="1024128"/>
-            <a:ext cx="10972800" cy="640080"/>
+            <a:ext cx="6400800" cy="640080"/>
           </a:xfrm>
           <a:prstGeom prst="rect">
             <a:avLst/>
@@ -33556,8 +33766,8 @@
         </p:nvSpPr>
         <p:spPr>
           <a:xfrm>
-            <a:off x="548640" y="2286000"/>
-            <a:ext cx="11064240" cy="3200400"/>
+            <a:off x="5349240" y="2148840"/>
+            <a:ext cx="6217920" cy="3566160"/>
           </a:xfrm>
           <a:prstGeom prst="roundRect">
             <a:avLst>
@@ -33602,8 +33812,8 @@
         </p:nvSpPr>
         <p:spPr>
           <a:xfrm>
-            <a:off x="914400" y="2560320"/>
-            <a:ext cx="10332720" cy="365760"/>
+            <a:off x="5623560" y="2377440"/>
+            <a:ext cx="5669280" cy="365760"/>
           </a:xfrm>
           <a:prstGeom prst="rect">
             <a:avLst/>
@@ -33643,8 +33853,8 @@
         </p:nvSpPr>
         <p:spPr>
           <a:xfrm>
-            <a:off x="914400" y="3108960"/>
-            <a:ext cx="10332720" cy="1828800"/>
+            <a:off x="5623560" y="2880360"/>
+            <a:ext cx="5669280" cy="2377440"/>
           </a:xfrm>
           <a:prstGeom prst="rect">
             <a:avLst/>
@@ -33663,7 +33873,7 @@
               </a:spcAft>
             </a:pPr>
             <a:r>
-              <a:rPr sz="2000" b="0" rtl="1" lang="ar-SA" altLang="en-US">
+              <a:rPr sz="1800" b="0" rtl="1" lang="ar-SA" altLang="en-US">
                 <a:solidFill>
                   <a:srgbClr val="121018"/>
                 </a:solidFill>
@@ -33676,6 +33886,76 @@
           </a:p>
         </p:txBody>
       </p:sp>
+      <p:sp>
+        <p:nvSpPr>
+          <p:cNvPr id="13" name="Rounded Rectangle 12"/>
+          <p:cNvSpPr/>
+          <p:nvPr/>
+        </p:nvSpPr>
+        <p:spPr>
+          <a:xfrm>
+            <a:off x="548640" y="2148840"/>
+            <a:ext cx="4480560" cy="3566160"/>
+          </a:xfrm>
+          <a:prstGeom prst="roundRect">
+            <a:avLst>
+              <a:gd name="adj" fmla="val 10000"/>
+            </a:avLst>
+          </a:prstGeom>
+          <a:solidFill>
+            <a:srgbClr val="F5F1FC"/>
+          </a:solidFill>
+          <a:ln>
+            <a:noFill/>
+          </a:ln>
+          <a:effectLst/>
+        </p:spPr>
+        <p:style>
+          <a:lnRef idx="1">
+            <a:schemeClr val="accent1"/>
+          </a:lnRef>
+          <a:fillRef idx="3">
+            <a:schemeClr val="accent1"/>
+          </a:fillRef>
+          <a:effectRef idx="2">
+            <a:schemeClr val="accent1"/>
+          </a:effectRef>
+          <a:fontRef idx="minor">
+            <a:schemeClr val="lt1"/>
+          </a:fontRef>
+        </p:style>
+        <p:txBody>
+          <a:bodyPr rtlCol="0" anchor="ctr"/>
+          <a:lstStyle/>
+          <a:p>
+            <a:pPr algn="ctr"/>
+          </a:p>
+        </p:txBody>
+      </p:sp>
+      <p:pic>
+        <p:nvPicPr>
+          <p:cNvPr id="14" name="Picture 13" descr=".crop-hero-media.jpg"/>
+          <p:cNvPicPr>
+            <a:picLocks noChangeAspect="1"/>
+          </p:cNvPicPr>
+          <p:nvPr/>
+        </p:nvPicPr>
+        <p:blipFill>
+          <a:blip r:embed="rId3"/>
+          <a:stretch>
+            <a:fillRect/>
+          </a:stretch>
+        </p:blipFill>
+        <p:spPr>
+          <a:xfrm>
+            <a:off x="713232" y="2331720"/>
+            <a:ext cx="4160520" cy="3200400"/>
+          </a:xfrm>
+          <a:prstGeom prst="rect">
+            <a:avLst/>
+          </a:prstGeom>
+        </p:spPr>
+      </p:pic>
     </p:spTree>
   </p:cSld>
   <p:clrMapOvr>
@@ -34844,7 +35124,7 @@
       </p:sp>
       <p:pic>
         <p:nvPicPr>
-          <p:cNvPr id="12" name="Picture 11" descr="icon-heygen.png"/>
+          <p:cNvPr id="12" name="Picture 11" descr=".pad-icon-heygen.png"/>
           <p:cNvPicPr>
             <a:picLocks noChangeAspect="1"/>
           </p:cNvPicPr>
@@ -35040,7 +35320,7 @@
       </p:sp>
       <p:pic>
         <p:nvPicPr>
-          <p:cNvPr id="17" name="Picture 16" descr="icon-elevenlabs.png"/>
+          <p:cNvPr id="17" name="Picture 16" descr=".pad-icon-elevenlabs.png"/>
           <p:cNvPicPr>
             <a:picLocks noChangeAspect="1"/>
           </p:cNvPicPr>
@@ -35236,7 +35516,7 @@
       </p:sp>
       <p:pic>
         <p:nvPicPr>
-          <p:cNvPr id="22" name="Picture 21" descr="icon-runway.png"/>
+          <p:cNvPr id="22" name="Picture 21" descr=".pad-icon-runway.png"/>
           <p:cNvPicPr>
             <a:picLocks noChangeAspect="1"/>
           </p:cNvPicPr>
@@ -38572,7 +38852,7 @@
       </p:sp>
       <p:pic>
         <p:nvPicPr>
-          <p:cNvPr id="14" name="Picture 13" descr="hero-laptop.jpg"/>
+          <p:cNvPr id="14" name="Picture 13" descr=".crop-hero-laptop.jpg"/>
           <p:cNvPicPr>
             <a:picLocks noChangeAspect="1"/>
           </p:cNvPicPr>
@@ -38586,8 +38866,8 @@
         </p:blipFill>
         <p:spPr>
           <a:xfrm>
-            <a:off x="652179340800" y="2331720"/>
-            <a:ext cx="4160520" cy="2769717"/>
+            <a:off x="713232" y="2331720"/>
+            <a:ext cx="4160520" cy="3200400"/>
           </a:xfrm>
           <a:prstGeom prst="rect">
             <a:avLst/>
@@ -42896,7 +43176,7 @@
       </p:sp>
       <p:pic>
         <p:nvPicPr>
-          <p:cNvPr id="7" name="Picture 6" descr="hero-day3.jpg"/>
+          <p:cNvPr id="7" name="Picture 6" descr=".crop-hero-day3.jpg"/>
           <p:cNvPicPr>
             <a:picLocks noChangeAspect="1"/>
           </p:cNvPicPr>
@@ -42910,8 +43190,8 @@
         </p:blipFill>
         <p:spPr>
           <a:xfrm>
-            <a:off x="627096079568" y="1371600"/>
-            <a:ext cx="2812783" cy="1874519"/>
+            <a:off x="685800" y="1371600"/>
+            <a:ext cx="3931920" cy="1874519"/>
           </a:xfrm>
           <a:prstGeom prst="rect">
             <a:avLst/>
@@ -43950,7 +44230,7 @@
       </p:sp>
       <p:pic>
         <p:nvPicPr>
-          <p:cNvPr id="14" name="Picture 13" descr="hero-data.jpg"/>
+          <p:cNvPr id="14" name="Picture 13" descr=".crop-hero-data.jpg"/>
           <p:cNvPicPr>
             <a:picLocks noChangeAspect="1"/>
           </p:cNvPicPr>
@@ -43964,8 +44244,8 @@
         </p:blipFill>
         <p:spPr>
           <a:xfrm>
-            <a:off x="652179340800" y="2331720"/>
-            <a:ext cx="4160520" cy="2962884"/>
+            <a:off x="713232" y="2331720"/>
+            <a:ext cx="4160520" cy="3200400"/>
           </a:xfrm>
           <a:prstGeom prst="rect">
             <a:avLst/>
@@ -45863,7 +46143,7 @@
       </p:sp>
       <p:pic>
         <p:nvPicPr>
-          <p:cNvPr id="12" name="Picture 11" descr="icon-openai.png"/>
+          <p:cNvPr id="12" name="Picture 11" descr=".pad-icon-openai.png"/>
           <p:cNvPicPr>
             <a:picLocks noChangeAspect="1"/>
           </p:cNvPicPr>
@@ -48309,7 +48589,7 @@
         <p:spPr>
           <a:xfrm>
             <a:off x="548640" y="1024128"/>
-            <a:ext cx="10972800" cy="640080"/>
+            <a:ext cx="6400800" cy="640080"/>
           </a:xfrm>
           <a:prstGeom prst="rect">
             <a:avLst/>
@@ -48349,8 +48629,8 @@
         </p:nvSpPr>
         <p:spPr>
           <a:xfrm>
-            <a:off x="548640" y="2286000"/>
-            <a:ext cx="11064240" cy="3200400"/>
+            <a:off x="5349240" y="2148840"/>
+            <a:ext cx="6217920" cy="3566160"/>
           </a:xfrm>
           <a:prstGeom prst="roundRect">
             <a:avLst>
@@ -48395,8 +48675,8 @@
         </p:nvSpPr>
         <p:spPr>
           <a:xfrm>
-            <a:off x="914400" y="2560320"/>
-            <a:ext cx="10332720" cy="365760"/>
+            <a:off x="5623560" y="2377440"/>
+            <a:ext cx="5669280" cy="365760"/>
           </a:xfrm>
           <a:prstGeom prst="rect">
             <a:avLst/>
@@ -48436,8 +48716,8 @@
         </p:nvSpPr>
         <p:spPr>
           <a:xfrm>
-            <a:off x="914400" y="3108960"/>
-            <a:ext cx="10332720" cy="1828800"/>
+            <a:off x="5623560" y="2880360"/>
+            <a:ext cx="5669280" cy="2377440"/>
           </a:xfrm>
           <a:prstGeom prst="rect">
             <a:avLst/>
@@ -48456,7 +48736,7 @@
               </a:spcAft>
             </a:pPr>
             <a:r>
-              <a:rPr sz="2000" b="0" rtl="1" lang="ar-SA" altLang="en-US">
+              <a:rPr sz="1800" b="0" rtl="1" lang="ar-SA" altLang="en-US">
                 <a:solidFill>
                   <a:srgbClr val="121018"/>
                 </a:solidFill>
@@ -48469,6 +48749,76 @@
           </a:p>
         </p:txBody>
       </p:sp>
+      <p:sp>
+        <p:nvSpPr>
+          <p:cNvPr id="13" name="Rounded Rectangle 12"/>
+          <p:cNvSpPr/>
+          <p:nvPr/>
+        </p:nvSpPr>
+        <p:spPr>
+          <a:xfrm>
+            <a:off x="548640" y="2148840"/>
+            <a:ext cx="4480560" cy="3566160"/>
+          </a:xfrm>
+          <a:prstGeom prst="roundRect">
+            <a:avLst>
+              <a:gd name="adj" fmla="val 10000"/>
+            </a:avLst>
+          </a:prstGeom>
+          <a:solidFill>
+            <a:srgbClr val="F5F1FC"/>
+          </a:solidFill>
+          <a:ln>
+            <a:noFill/>
+          </a:ln>
+          <a:effectLst/>
+        </p:spPr>
+        <p:style>
+          <a:lnRef idx="1">
+            <a:schemeClr val="accent1"/>
+          </a:lnRef>
+          <a:fillRef idx="3">
+            <a:schemeClr val="accent1"/>
+          </a:fillRef>
+          <a:effectRef idx="2">
+            <a:schemeClr val="accent1"/>
+          </a:effectRef>
+          <a:fontRef idx="minor">
+            <a:schemeClr val="lt1"/>
+          </a:fontRef>
+        </p:style>
+        <p:txBody>
+          <a:bodyPr rtlCol="0" anchor="ctr"/>
+          <a:lstStyle/>
+          <a:p>
+            <a:pPr algn="ctr"/>
+          </a:p>
+        </p:txBody>
+      </p:sp>
+      <p:pic>
+        <p:nvPicPr>
+          <p:cNvPr id="14" name="Picture 13" descr=".crop-hero-automation.jpg"/>
+          <p:cNvPicPr>
+            <a:picLocks noChangeAspect="1"/>
+          </p:cNvPicPr>
+          <p:nvPr/>
+        </p:nvPicPr>
+        <p:blipFill>
+          <a:blip r:embed="rId3"/>
+          <a:stretch>
+            <a:fillRect/>
+          </a:stretch>
+        </p:blipFill>
+        <p:spPr>
+          <a:xfrm>
+            <a:off x="713232" y="2331720"/>
+            <a:ext cx="4160520" cy="3200400"/>
+          </a:xfrm>
+          <a:prstGeom prst="rect">
+            <a:avLst/>
+          </a:prstGeom>
+        </p:spPr>
+      </p:pic>
     </p:spTree>
   </p:cSld>
   <p:clrMapOvr>
@@ -50360,7 +50710,7 @@
       </p:sp>
       <p:pic>
         <p:nvPicPr>
-          <p:cNvPr id="12" name="Picture 11" descr="icon-zapier.png"/>
+          <p:cNvPr id="12" name="Picture 11" descr=".pad-icon-zapier.png"/>
           <p:cNvPicPr>
             <a:picLocks noChangeAspect="1"/>
           </p:cNvPicPr>
@@ -50556,7 +50906,7 @@
       </p:sp>
       <p:pic>
         <p:nvPicPr>
-          <p:cNvPr id="17" name="Picture 16" descr="icon-make.png"/>
+          <p:cNvPr id="17" name="Picture 16" descr=".pad-icon-make.png"/>
           <p:cNvPicPr>
             <a:picLocks noChangeAspect="1"/>
           </p:cNvPicPr>
@@ -52139,7 +52489,7 @@
         <p:spPr>
           <a:xfrm>
             <a:off x="548640" y="1024128"/>
-            <a:ext cx="10972800" cy="640080"/>
+            <a:ext cx="6400800" cy="640080"/>
           </a:xfrm>
           <a:prstGeom prst="rect">
             <a:avLst/>
@@ -52179,8 +52529,8 @@
         </p:nvSpPr>
         <p:spPr>
           <a:xfrm>
-            <a:off x="548640" y="2286000"/>
-            <a:ext cx="11064240" cy="3200400"/>
+            <a:off x="5349240" y="2148840"/>
+            <a:ext cx="6217920" cy="3566160"/>
           </a:xfrm>
           <a:prstGeom prst="roundRect">
             <a:avLst>
@@ -52225,8 +52575,8 @@
         </p:nvSpPr>
         <p:spPr>
           <a:xfrm>
-            <a:off x="914400" y="2560320"/>
-            <a:ext cx="10332720" cy="365760"/>
+            <a:off x="5623560" y="2377440"/>
+            <a:ext cx="5669280" cy="365760"/>
           </a:xfrm>
           <a:prstGeom prst="rect">
             <a:avLst/>
@@ -52266,8 +52616,8 @@
         </p:nvSpPr>
         <p:spPr>
           <a:xfrm>
-            <a:off x="914400" y="3108960"/>
-            <a:ext cx="10332720" cy="1828800"/>
+            <a:off x="5623560" y="2880360"/>
+            <a:ext cx="5669280" cy="2377440"/>
           </a:xfrm>
           <a:prstGeom prst="rect">
             <a:avLst/>
@@ -52286,7 +52636,7 @@
               </a:spcAft>
             </a:pPr>
             <a:r>
-              <a:rPr sz="2000" b="0" rtl="1" lang="ar-SA" altLang="en-US">
+              <a:rPr sz="1800" b="0" rtl="1" lang="ar-SA" altLang="en-US">
                 <a:solidFill>
                   <a:srgbClr val="121018"/>
                 </a:solidFill>
@@ -52299,6 +52649,76 @@
           </a:p>
         </p:txBody>
       </p:sp>
+      <p:sp>
+        <p:nvSpPr>
+          <p:cNvPr id="13" name="Rounded Rectangle 12"/>
+          <p:cNvSpPr/>
+          <p:nvPr/>
+        </p:nvSpPr>
+        <p:spPr>
+          <a:xfrm>
+            <a:off x="548640" y="2148840"/>
+            <a:ext cx="4480560" cy="3566160"/>
+          </a:xfrm>
+          <a:prstGeom prst="roundRect">
+            <a:avLst>
+              <a:gd name="adj" fmla="val 10000"/>
+            </a:avLst>
+          </a:prstGeom>
+          <a:solidFill>
+            <a:srgbClr val="F5F1FC"/>
+          </a:solidFill>
+          <a:ln>
+            <a:noFill/>
+          </a:ln>
+          <a:effectLst/>
+        </p:spPr>
+        <p:style>
+          <a:lnRef idx="1">
+            <a:schemeClr val="accent1"/>
+          </a:lnRef>
+          <a:fillRef idx="3">
+            <a:schemeClr val="accent1"/>
+          </a:fillRef>
+          <a:effectRef idx="2">
+            <a:schemeClr val="accent1"/>
+          </a:effectRef>
+          <a:fontRef idx="minor">
+            <a:schemeClr val="lt1"/>
+          </a:fontRef>
+        </p:style>
+        <p:txBody>
+          <a:bodyPr rtlCol="0" anchor="ctr"/>
+          <a:lstStyle/>
+          <a:p>
+            <a:pPr algn="ctr"/>
+          </a:p>
+        </p:txBody>
+      </p:sp>
+      <p:pic>
+        <p:nvPicPr>
+          <p:cNvPr id="14" name="Picture 13" descr=".crop-hero-team.jpg"/>
+          <p:cNvPicPr>
+            <a:picLocks noChangeAspect="1"/>
+          </p:cNvPicPr>
+          <p:nvPr/>
+        </p:nvPicPr>
+        <p:blipFill>
+          <a:blip r:embed="rId3"/>
+          <a:stretch>
+            <a:fillRect/>
+          </a:stretch>
+        </p:blipFill>
+        <p:spPr>
+          <a:xfrm>
+            <a:off x="713232" y="2331720"/>
+            <a:ext cx="4160520" cy="3200400"/>
+          </a:xfrm>
+          <a:prstGeom prst="rect">
+            <a:avLst/>
+          </a:prstGeom>
+        </p:spPr>
+      </p:pic>
     </p:spTree>
   </p:cSld>
   <p:clrMapOvr>
@@ -56825,7 +57245,7 @@
       </p:sp>
       <p:pic>
         <p:nvPicPr>
-          <p:cNvPr id="12" name="Picture 11" descr="icon-openai.png"/>
+          <p:cNvPr id="12" name="Picture 11" descr=".pad-icon-openai.png"/>
           <p:cNvPicPr>
             <a:picLocks noChangeAspect="1"/>
           </p:cNvPicPr>
@@ -57021,7 +57441,7 @@
       </p:sp>
       <p:pic>
         <p:nvPicPr>
-          <p:cNvPr id="17" name="Picture 16" descr="icon-poe.png"/>
+          <p:cNvPr id="17" name="Picture 16" descr=".pad-icon-poe.png"/>
           <p:cNvPicPr>
             <a:picLocks noChangeAspect="1"/>
           </p:cNvPicPr>
@@ -64655,7 +65075,7 @@
       </p:sp>
       <p:pic>
         <p:nvPicPr>
-          <p:cNvPr id="13" name="Picture 12" descr="icon-openai.png"/>
+          <p:cNvPr id="13" name="Picture 12" descr=".pad-icon-openai.png"/>
           <p:cNvPicPr>
             <a:picLocks noChangeAspect="1"/>
           </p:cNvPicPr>
@@ -64851,7 +65271,7 @@
       </p:sp>
       <p:pic>
         <p:nvPicPr>
-          <p:cNvPr id="18" name="Picture 17" descr="icon-perplexity.png"/>
+          <p:cNvPr id="18" name="Picture 17" descr=".pad-icon-perplexity.png"/>
           <p:cNvPicPr>
             <a:picLocks noChangeAspect="1"/>
           </p:cNvPicPr>
@@ -65047,7 +65467,7 @@
       </p:sp>
       <p:pic>
         <p:nvPicPr>
-          <p:cNvPr id="23" name="Picture 22" descr="icon-heygen.png"/>
+          <p:cNvPr id="23" name="Picture 22" descr=".pad-icon-heygen.png"/>
           <p:cNvPicPr>
             <a:picLocks noChangeAspect="1"/>
           </p:cNvPicPr>
@@ -65416,7 +65836,7 @@
       </p:sp>
       <p:pic>
         <p:nvPicPr>
-          <p:cNvPr id="8" name="Picture 7" descr="hero-team.jpg"/>
+          <p:cNvPr id="8" name="Picture 7" descr=".crop-hero-team.jpg"/>
           <p:cNvPicPr>
             <a:picLocks noChangeAspect="1"/>
           </p:cNvPicPr>
@@ -65430,8 +65850,8 @@
         </p:blipFill>
         <p:spPr>
           <a:xfrm>
-            <a:off x="5189856" y="4663440"/>
-            <a:ext cx="1781807" cy="1188720"/>
+            <a:off x="4160520" y="4663440"/>
+            <a:ext cx="3840480" cy="1188720"/>
           </a:xfrm>
           <a:prstGeom prst="rect">
             <a:avLst/>

</xml_diff>

<commit_message>
chore: update ETRA AI Tools Workshop materials with revised PDF and PPTX exports, enhancing content alignment and RTL support for improved presentation quality
</commit_message>
<xml_diff>
--- a/web-presentation/pdf-exports/ETRA-AI-Tools-Workshop-3Days-AR.pptx
+++ b/web-presentation/pdf-exports/ETRA-AI-Tools-Workshop-3Days-AR.pptx
@@ -3621,7 +3621,7 @@
               </a:spcAft>
             </a:pPr>
             <a:r>
-              <a:rPr sz="1100" b="0" rtl="1" lang="ar-SA" altLang="en-US">
+              <a:rPr sz="1100" b="0" rtl="0" lang="en-US" altLang="ar-SA">
                 <a:solidFill>
                   <a:srgbClr val="5A5470"/>
                 </a:solidFill>
@@ -3926,7 +3926,7 @@
               </a:spcAft>
             </a:pPr>
             <a:r>
-              <a:rPr sz="1100" b="0" rtl="1" lang="ar-SA" altLang="en-US">
+              <a:rPr sz="1100" b="0" rtl="0" lang="en-US" altLang="ar-SA">
                 <a:solidFill>
                   <a:srgbClr val="5A5470"/>
                 </a:solidFill>
@@ -4337,7 +4337,7 @@
               </a:spcAft>
             </a:pPr>
             <a:r>
-              <a:rPr sz="1100" b="0" rtl="1" lang="ar-SA" altLang="en-US">
+              <a:rPr sz="1100" b="0" rtl="0" lang="en-US" altLang="ar-SA">
                 <a:solidFill>
                   <a:srgbClr val="5A5470"/>
                 </a:solidFill>
@@ -4546,7 +4546,7 @@
           </a:bodyPr>
           <a:lstStyle/>
           <a:p>
-            <a:pPr algn="ctr" rtl="1">
+            <a:pPr algn="ctr">
               <a:spcAft>
                 <a:spcPts val="400"/>
               </a:spcAft>
@@ -4720,7 +4720,7 @@
           </a:bodyPr>
           <a:lstStyle/>
           <a:p>
-            <a:pPr algn="ctr" rtl="1">
+            <a:pPr algn="ctr">
               <a:spcAft>
                 <a:spcPts val="400"/>
               </a:spcAft>
@@ -4894,7 +4894,7 @@
           </a:bodyPr>
           <a:lstStyle/>
           <a:p>
-            <a:pPr algn="ctr" rtl="1">
+            <a:pPr algn="ctr">
               <a:spcAft>
                 <a:spcPts val="400"/>
               </a:spcAft>
@@ -5068,7 +5068,7 @@
           </a:bodyPr>
           <a:lstStyle/>
           <a:p>
-            <a:pPr algn="ctr" rtl="1">
+            <a:pPr algn="ctr">
               <a:spcAft>
                 <a:spcPts val="400"/>
               </a:spcAft>
@@ -5242,7 +5242,7 @@
           </a:bodyPr>
           <a:lstStyle/>
           <a:p>
-            <a:pPr algn="ctr" rtl="1">
+            <a:pPr algn="ctr">
               <a:spcAft>
                 <a:spcPts val="400"/>
               </a:spcAft>
@@ -5594,7 +5594,7 @@
               </a:spcAft>
             </a:pPr>
             <a:r>
-              <a:rPr sz="1100" b="0" rtl="1" lang="ar-SA" altLang="en-US">
+              <a:rPr sz="1100" b="0" rtl="0" lang="en-US" altLang="ar-SA">
                 <a:solidFill>
                   <a:srgbClr val="5A5470"/>
                 </a:solidFill>
@@ -5635,7 +5635,7 @@
               </a:spcAft>
             </a:pPr>
             <a:r>
-              <a:rPr sz="3200" b="1" rtl="1" lang="ar-SA" altLang="en-US">
+              <a:rPr sz="2800" b="1" rtl="1" lang="ar-SA" altLang="en-US">
                 <a:solidFill>
                   <a:srgbClr val="5234B7"/>
                 </a:solidFill>
@@ -5803,7 +5803,7 @@
           </a:bodyPr>
           <a:lstStyle/>
           <a:p>
-            <a:pPr algn="ctr" rtl="1">
+            <a:pPr algn="ctr">
               <a:spcAft>
                 <a:spcPts val="400"/>
               </a:spcAft>
@@ -5977,7 +5977,7 @@
           </a:bodyPr>
           <a:lstStyle/>
           <a:p>
-            <a:pPr algn="ctr" rtl="1">
+            <a:pPr algn="ctr">
               <a:spcAft>
                 <a:spcPts val="400"/>
               </a:spcAft>
@@ -6151,7 +6151,7 @@
           </a:bodyPr>
           <a:lstStyle/>
           <a:p>
-            <a:pPr algn="ctr" rtl="1">
+            <a:pPr algn="ctr">
               <a:spcAft>
                 <a:spcPts val="400"/>
               </a:spcAft>
@@ -6325,7 +6325,7 @@
           </a:bodyPr>
           <a:lstStyle/>
           <a:p>
-            <a:pPr algn="ctr" rtl="1">
+            <a:pPr algn="ctr">
               <a:spcAft>
                 <a:spcPts val="400"/>
               </a:spcAft>
@@ -6677,7 +6677,7 @@
               </a:spcAft>
             </a:pPr>
             <a:r>
-              <a:rPr sz="1100" b="0" rtl="1" lang="ar-SA" altLang="en-US">
+              <a:rPr sz="1100" b="0" rtl="0" lang="en-US" altLang="ar-SA">
                 <a:solidFill>
                   <a:srgbClr val="5A5470"/>
                 </a:solidFill>
@@ -7088,7 +7088,7 @@
               </a:spcAft>
             </a:pPr>
             <a:r>
-              <a:rPr sz="1100" b="0" rtl="1" lang="ar-SA" altLang="en-US">
+              <a:rPr sz="1100" b="0" rtl="0" lang="en-US" altLang="ar-SA">
                 <a:solidFill>
                   <a:srgbClr val="5A5470"/>
                 </a:solidFill>
@@ -7297,7 +7297,7 @@
           </a:bodyPr>
           <a:lstStyle/>
           <a:p>
-            <a:pPr algn="ctr" rtl="1">
+            <a:pPr algn="ctr">
               <a:spcAft>
                 <a:spcPts val="400"/>
               </a:spcAft>
@@ -7471,7 +7471,7 @@
           </a:bodyPr>
           <a:lstStyle/>
           <a:p>
-            <a:pPr algn="ctr" rtl="1">
+            <a:pPr algn="ctr">
               <a:spcAft>
                 <a:spcPts val="400"/>
               </a:spcAft>
@@ -7645,7 +7645,7 @@
           </a:bodyPr>
           <a:lstStyle/>
           <a:p>
-            <a:pPr algn="ctr" rtl="1">
+            <a:pPr algn="ctr">
               <a:spcAft>
                 <a:spcPts val="400"/>
               </a:spcAft>
@@ -7819,7 +7819,7 @@
           </a:bodyPr>
           <a:lstStyle/>
           <a:p>
-            <a:pPr algn="ctr" rtl="1">
+            <a:pPr algn="ctr">
               <a:spcAft>
                 <a:spcPts val="400"/>
               </a:spcAft>
@@ -7993,7 +7993,7 @@
           </a:bodyPr>
           <a:lstStyle/>
           <a:p>
-            <a:pPr algn="ctr" rtl="1">
+            <a:pPr algn="ctr">
               <a:spcAft>
                 <a:spcPts val="400"/>
               </a:spcAft>
@@ -8167,7 +8167,7 @@
           </a:bodyPr>
           <a:lstStyle/>
           <a:p>
-            <a:pPr algn="ctr" rtl="1">
+            <a:pPr algn="ctr">
               <a:spcAft>
                 <a:spcPts val="400"/>
               </a:spcAft>
@@ -8543,7 +8543,7 @@
               </a:spcAft>
             </a:pPr>
             <a:r>
-              <a:rPr sz="1100" b="0" rtl="1" lang="ar-SA" altLang="en-US">
+              <a:rPr sz="1100" b="0" rtl="0" lang="en-US" altLang="ar-SA">
                 <a:solidFill>
                   <a:srgbClr val="5A5470"/>
                 </a:solidFill>
@@ -8954,7 +8954,7 @@
               </a:spcAft>
             </a:pPr>
             <a:r>
-              <a:rPr sz="1100" b="0" rtl="1" lang="ar-SA" altLang="en-US">
+              <a:rPr sz="1100" b="0" rtl="0" lang="en-US" altLang="ar-SA">
                 <a:solidFill>
                   <a:srgbClr val="5A5470"/>
                 </a:solidFill>
@@ -9725,7 +9725,7 @@
               </a:spcAft>
             </a:pPr>
             <a:r>
-              <a:rPr sz="1100" b="0" rtl="1" lang="ar-SA" altLang="en-US">
+              <a:rPr sz="1100" b="0" rtl="0" lang="en-US" altLang="ar-SA">
                 <a:solidFill>
                   <a:srgbClr val="5A5470"/>
                 </a:solidFill>
@@ -10496,7 +10496,7 @@
               </a:spcAft>
             </a:pPr>
             <a:r>
-              <a:rPr sz="1100" b="0" rtl="1" lang="ar-SA" altLang="en-US">
+              <a:rPr sz="1100" b="0" rtl="0" lang="en-US" altLang="ar-SA">
                 <a:solidFill>
                   <a:srgbClr val="5A5470"/>
                 </a:solidFill>
@@ -11267,7 +11267,7 @@
               </a:spcAft>
             </a:pPr>
             <a:r>
-              <a:rPr sz="1100" b="0" rtl="1" lang="ar-SA" altLang="en-US">
+              <a:rPr sz="1100" b="0" rtl="0" lang="en-US" altLang="ar-SA">
                 <a:solidFill>
                   <a:srgbClr val="5A5470"/>
                 </a:solidFill>
@@ -11498,7 +11498,7 @@
           </a:bodyPr>
           <a:lstStyle/>
           <a:p>
-            <a:pPr algn="ctr" rtl="1">
+            <a:pPr algn="ctr">
               <a:spcAft>
                 <a:spcPts val="600"/>
               </a:spcAft>
@@ -11539,7 +11539,7 @@
           </a:bodyPr>
           <a:lstStyle/>
           <a:p>
-            <a:pPr algn="ctr" rtl="1">
+            <a:pPr algn="ctr">
               <a:spcAft>
                 <a:spcPts val="400"/>
               </a:spcAft>
@@ -11694,7 +11694,7 @@
           </a:bodyPr>
           <a:lstStyle/>
           <a:p>
-            <a:pPr algn="ctr" rtl="1">
+            <a:pPr algn="ctr">
               <a:spcAft>
                 <a:spcPts val="600"/>
               </a:spcAft>
@@ -11735,7 +11735,7 @@
           </a:bodyPr>
           <a:lstStyle/>
           <a:p>
-            <a:pPr algn="ctr" rtl="1">
+            <a:pPr algn="ctr">
               <a:spcAft>
                 <a:spcPts val="400"/>
               </a:spcAft>
@@ -11890,7 +11890,7 @@
           </a:bodyPr>
           <a:lstStyle/>
           <a:p>
-            <a:pPr algn="ctr" rtl="1">
+            <a:pPr algn="ctr">
               <a:spcAft>
                 <a:spcPts val="600"/>
               </a:spcAft>
@@ -11931,7 +11931,7 @@
           </a:bodyPr>
           <a:lstStyle/>
           <a:p>
-            <a:pPr algn="ctr" rtl="1">
+            <a:pPr algn="ctr">
               <a:spcAft>
                 <a:spcPts val="400"/>
               </a:spcAft>
@@ -12242,7 +12242,7 @@
               </a:spcAft>
             </a:pPr>
             <a:r>
-              <a:rPr sz="1100" b="0" rtl="1" lang="ar-SA" altLang="en-US">
+              <a:rPr sz="1100" b="0" rtl="0" lang="en-US" altLang="ar-SA">
                 <a:solidFill>
                   <a:srgbClr val="5A5470"/>
                 </a:solidFill>
@@ -12653,7 +12653,7 @@
               </a:spcAft>
             </a:pPr>
             <a:r>
-              <a:rPr sz="1100" b="0" rtl="1" lang="ar-SA" altLang="en-US">
+              <a:rPr sz="1100" b="0" rtl="0" lang="en-US" altLang="ar-SA">
                 <a:solidFill>
                   <a:srgbClr val="5A5470"/>
                 </a:solidFill>
@@ -12862,7 +12862,7 @@
           </a:bodyPr>
           <a:lstStyle/>
           <a:p>
-            <a:pPr algn="ctr" rtl="1">
+            <a:pPr algn="ctr">
               <a:spcAft>
                 <a:spcPts val="400"/>
               </a:spcAft>
@@ -13036,7 +13036,7 @@
           </a:bodyPr>
           <a:lstStyle/>
           <a:p>
-            <a:pPr algn="ctr" rtl="1">
+            <a:pPr algn="ctr">
               <a:spcAft>
                 <a:spcPts val="400"/>
               </a:spcAft>
@@ -13210,7 +13210,7 @@
           </a:bodyPr>
           <a:lstStyle/>
           <a:p>
-            <a:pPr algn="ctr" rtl="1">
+            <a:pPr algn="ctr">
               <a:spcAft>
                 <a:spcPts val="400"/>
               </a:spcAft>
@@ -13384,7 +13384,7 @@
           </a:bodyPr>
           <a:lstStyle/>
           <a:p>
-            <a:pPr algn="ctr" rtl="1">
+            <a:pPr algn="ctr">
               <a:spcAft>
                 <a:spcPts val="400"/>
               </a:spcAft>
@@ -13558,7 +13558,7 @@
           </a:bodyPr>
           <a:lstStyle/>
           <a:p>
-            <a:pPr algn="ctr" rtl="1">
+            <a:pPr algn="ctr">
               <a:spcAft>
                 <a:spcPts val="400"/>
               </a:spcAft>
@@ -13910,7 +13910,7 @@
               </a:spcAft>
             </a:pPr>
             <a:r>
-              <a:rPr sz="1100" b="0" rtl="1" lang="ar-SA" altLang="en-US">
+              <a:rPr sz="1100" b="0" rtl="0" lang="en-US" altLang="ar-SA">
                 <a:solidFill>
                   <a:srgbClr val="5A5470"/>
                 </a:solidFill>
@@ -14321,7 +14321,7 @@
               </a:spcAft>
             </a:pPr>
             <a:r>
-              <a:rPr sz="1100" b="0" rtl="1" lang="ar-SA" altLang="en-US">
+              <a:rPr sz="1100" b="0" rtl="0" lang="en-US" altLang="ar-SA">
                 <a:solidFill>
                   <a:srgbClr val="5A5470"/>
                 </a:solidFill>
@@ -14342,8 +14342,8 @@
         </p:nvSpPr>
         <p:spPr>
           <a:xfrm>
-            <a:off x="548640" y="1024128"/>
-            <a:ext cx="6400800" cy="640080"/>
+            <a:off x="5349240" y="1024128"/>
+            <a:ext cx="6217920" cy="640080"/>
           </a:xfrm>
           <a:prstGeom prst="rect">
             <a:avLst/>
@@ -14429,8 +14429,8 @@
         </p:nvSpPr>
         <p:spPr>
           <a:xfrm>
-            <a:off x="5623560" y="2377440"/>
-            <a:ext cx="5669280" cy="365760"/>
+            <a:off x="5669280" y="2377440"/>
+            <a:ext cx="5577840" cy="365760"/>
           </a:xfrm>
           <a:prstGeom prst="rect">
             <a:avLst/>
@@ -14470,8 +14470,8 @@
         </p:nvSpPr>
         <p:spPr>
           <a:xfrm>
-            <a:off x="5623560" y="2880360"/>
-            <a:ext cx="5669280" cy="2377440"/>
+            <a:off x="5669280" y="2880360"/>
+            <a:ext cx="5577840" cy="2377440"/>
           </a:xfrm>
           <a:prstGeom prst="rect">
             <a:avLst/>
@@ -14865,7 +14865,7 @@
               </a:spcAft>
             </a:pPr>
             <a:r>
-              <a:rPr sz="1100" b="0" rtl="1" lang="ar-SA" altLang="en-US">
+              <a:rPr sz="1100" b="0" rtl="0" lang="en-US" altLang="ar-SA">
                 <a:solidFill>
                   <a:srgbClr val="5A5470"/>
                 </a:solidFill>
@@ -15074,7 +15074,7 @@
           </a:bodyPr>
           <a:lstStyle/>
           <a:p>
-            <a:pPr algn="ctr" rtl="1">
+            <a:pPr algn="ctr">
               <a:spcAft>
                 <a:spcPts val="400"/>
               </a:spcAft>
@@ -15248,7 +15248,7 @@
           </a:bodyPr>
           <a:lstStyle/>
           <a:p>
-            <a:pPr algn="ctr" rtl="1">
+            <a:pPr algn="ctr">
               <a:spcAft>
                 <a:spcPts val="400"/>
               </a:spcAft>
@@ -15422,7 +15422,7 @@
           </a:bodyPr>
           <a:lstStyle/>
           <a:p>
-            <a:pPr algn="ctr" rtl="1">
+            <a:pPr algn="ctr">
               <a:spcAft>
                 <a:spcPts val="400"/>
               </a:spcAft>
@@ -15596,7 +15596,7 @@
           </a:bodyPr>
           <a:lstStyle/>
           <a:p>
-            <a:pPr algn="ctr" rtl="1">
+            <a:pPr algn="ctr">
               <a:spcAft>
                 <a:spcPts val="400"/>
               </a:spcAft>
@@ -15770,7 +15770,7 @@
           </a:bodyPr>
           <a:lstStyle/>
           <a:p>
-            <a:pPr algn="ctr" rtl="1">
+            <a:pPr algn="ctr">
               <a:spcAft>
                 <a:spcPts val="400"/>
               </a:spcAft>
@@ -16122,7 +16122,7 @@
               </a:spcAft>
             </a:pPr>
             <a:r>
-              <a:rPr sz="1100" b="0" rtl="1" lang="ar-SA" altLang="en-US">
+              <a:rPr sz="1100" b="0" rtl="0" lang="en-US" altLang="ar-SA">
                 <a:solidFill>
                   <a:srgbClr val="5A5470"/>
                 </a:solidFill>
@@ -16331,7 +16331,7 @@
           </a:bodyPr>
           <a:lstStyle/>
           <a:p>
-            <a:pPr algn="ctr" rtl="1">
+            <a:pPr algn="ctr">
               <a:spcAft>
                 <a:spcPts val="400"/>
               </a:spcAft>
@@ -16505,7 +16505,7 @@
           </a:bodyPr>
           <a:lstStyle/>
           <a:p>
-            <a:pPr algn="ctr" rtl="1">
+            <a:pPr algn="ctr">
               <a:spcAft>
                 <a:spcPts val="400"/>
               </a:spcAft>
@@ -16679,7 +16679,7 @@
           </a:bodyPr>
           <a:lstStyle/>
           <a:p>
-            <a:pPr algn="ctr" rtl="1">
+            <a:pPr algn="ctr">
               <a:spcAft>
                 <a:spcPts val="400"/>
               </a:spcAft>
@@ -16853,7 +16853,7 @@
           </a:bodyPr>
           <a:lstStyle/>
           <a:p>
-            <a:pPr algn="ctr" rtl="1">
+            <a:pPr algn="ctr">
               <a:spcAft>
                 <a:spcPts val="400"/>
               </a:spcAft>
@@ -17205,7 +17205,7 @@
               </a:spcAft>
             </a:pPr>
             <a:r>
-              <a:rPr sz="1100" b="0" rtl="1" lang="ar-SA" altLang="en-US">
+              <a:rPr sz="1100" b="0" rtl="0" lang="en-US" altLang="ar-SA">
                 <a:solidFill>
                   <a:srgbClr val="5A5470"/>
                 </a:solidFill>
@@ -17976,7 +17976,7 @@
               </a:spcAft>
             </a:pPr>
             <a:r>
-              <a:rPr sz="1100" b="0" rtl="1" lang="ar-SA" altLang="en-US">
+              <a:rPr sz="1100" b="0" rtl="0" lang="en-US" altLang="ar-SA">
                 <a:solidFill>
                   <a:srgbClr val="5A5470"/>
                 </a:solidFill>
@@ -18387,7 +18387,7 @@
               </a:spcAft>
             </a:pPr>
             <a:r>
-              <a:rPr sz="1100" b="0" rtl="1" lang="ar-SA" altLang="en-US">
+              <a:rPr sz="1100" b="0" rtl="0" lang="en-US" altLang="ar-SA">
                 <a:solidFill>
                   <a:srgbClr val="5A5470"/>
                 </a:solidFill>
@@ -19158,7 +19158,7 @@
               </a:spcAft>
             </a:pPr>
             <a:r>
-              <a:rPr sz="1100" b="0" rtl="1" lang="ar-SA" altLang="en-US">
+              <a:rPr sz="1100" b="0" rtl="0" lang="en-US" altLang="ar-SA">
                 <a:solidFill>
                   <a:srgbClr val="5A5470"/>
                 </a:solidFill>
@@ -19179,8 +19179,8 @@
         </p:nvSpPr>
         <p:spPr>
           <a:xfrm>
-            <a:off x="548640" y="1024128"/>
-            <a:ext cx="6400800" cy="640080"/>
+            <a:off x="5349240" y="1024128"/>
+            <a:ext cx="6217920" cy="640080"/>
           </a:xfrm>
           <a:prstGeom prst="rect">
             <a:avLst/>
@@ -19266,8 +19266,8 @@
         </p:nvSpPr>
         <p:spPr>
           <a:xfrm>
-            <a:off x="5623560" y="2377440"/>
-            <a:ext cx="5669280" cy="365760"/>
+            <a:off x="5669280" y="2377440"/>
+            <a:ext cx="5577840" cy="365760"/>
           </a:xfrm>
           <a:prstGeom prst="rect">
             <a:avLst/>
@@ -19307,8 +19307,8 @@
         </p:nvSpPr>
         <p:spPr>
           <a:xfrm>
-            <a:off x="5623560" y="2880360"/>
-            <a:ext cx="5669280" cy="2377440"/>
+            <a:off x="5669280" y="2880360"/>
+            <a:ext cx="5577840" cy="2377440"/>
           </a:xfrm>
           <a:prstGeom prst="rect">
             <a:avLst/>
@@ -19335,7 +19335,7 @@
                 <a:ea typeface="IBM Plex Sans Arabic"/>
                 <a:cs typeface="IBM Plex Sans Arabic"/>
               </a:rPr>
-              <a:t>مسار موثوق: مصادر → تلخيص ملف → مخرج عمل — بلا اختلاق</a:t>
+              <a:t>مسار موثوق: من المصادر، إلى تلخيص الملف، إلى مخرج عمل — بلا اختلاق</a:t>
             </a:r>
           </a:p>
         </p:txBody>
@@ -19702,7 +19702,7 @@
               </a:spcAft>
             </a:pPr>
             <a:r>
-              <a:rPr sz="1100" b="0" rtl="1" lang="ar-SA" altLang="en-US">
+              <a:rPr sz="1100" b="0" rtl="0" lang="en-US" altLang="ar-SA">
                 <a:solidFill>
                   <a:srgbClr val="5A5470"/>
                 </a:solidFill>
@@ -19933,7 +19933,7 @@
           </a:bodyPr>
           <a:lstStyle/>
           <a:p>
-            <a:pPr algn="ctr" rtl="1">
+            <a:pPr algn="ctr">
               <a:spcAft>
                 <a:spcPts val="600"/>
               </a:spcAft>
@@ -19974,7 +19974,7 @@
           </a:bodyPr>
           <a:lstStyle/>
           <a:p>
-            <a:pPr algn="ctr" rtl="1">
+            <a:pPr algn="ctr">
               <a:spcAft>
                 <a:spcPts val="400"/>
               </a:spcAft>
@@ -20129,7 +20129,7 @@
           </a:bodyPr>
           <a:lstStyle/>
           <a:p>
-            <a:pPr algn="ctr" rtl="1">
+            <a:pPr algn="ctr">
               <a:spcAft>
                 <a:spcPts val="600"/>
               </a:spcAft>
@@ -20170,7 +20170,7 @@
           </a:bodyPr>
           <a:lstStyle/>
           <a:p>
-            <a:pPr algn="ctr" rtl="1">
+            <a:pPr algn="ctr">
               <a:spcAft>
                 <a:spcPts val="400"/>
               </a:spcAft>
@@ -20325,7 +20325,7 @@
           </a:bodyPr>
           <a:lstStyle/>
           <a:p>
-            <a:pPr algn="ctr" rtl="1">
+            <a:pPr algn="ctr">
               <a:spcAft>
                 <a:spcPts val="600"/>
               </a:spcAft>
@@ -20366,7 +20366,7 @@
           </a:bodyPr>
           <a:lstStyle/>
           <a:p>
-            <a:pPr algn="ctr" rtl="1">
+            <a:pPr algn="ctr">
               <a:spcAft>
                 <a:spcPts val="400"/>
               </a:spcAft>
@@ -20677,7 +20677,7 @@
               </a:spcAft>
             </a:pPr>
             <a:r>
-              <a:rPr sz="1100" b="0" rtl="1" lang="ar-SA" altLang="en-US">
+              <a:rPr sz="1100" b="0" rtl="0" lang="en-US" altLang="ar-SA">
                 <a:solidFill>
                   <a:srgbClr val="5A5470"/>
                 </a:solidFill>
@@ -20886,7 +20886,7 @@
           </a:bodyPr>
           <a:lstStyle/>
           <a:p>
-            <a:pPr algn="ctr" rtl="1">
+            <a:pPr algn="ctr">
               <a:spcAft>
                 <a:spcPts val="400"/>
               </a:spcAft>
@@ -21060,7 +21060,7 @@
           </a:bodyPr>
           <a:lstStyle/>
           <a:p>
-            <a:pPr algn="ctr" rtl="1">
+            <a:pPr algn="ctr">
               <a:spcAft>
                 <a:spcPts val="400"/>
               </a:spcAft>
@@ -21234,7 +21234,7 @@
           </a:bodyPr>
           <a:lstStyle/>
           <a:p>
-            <a:pPr algn="ctr" rtl="1">
+            <a:pPr algn="ctr">
               <a:spcAft>
                 <a:spcPts val="400"/>
               </a:spcAft>
@@ -21408,7 +21408,7 @@
           </a:bodyPr>
           <a:lstStyle/>
           <a:p>
-            <a:pPr algn="ctr" rtl="1">
+            <a:pPr algn="ctr">
               <a:spcAft>
                 <a:spcPts val="400"/>
               </a:spcAft>
@@ -21582,7 +21582,7 @@
           </a:bodyPr>
           <a:lstStyle/>
           <a:p>
-            <a:pPr algn="ctr" rtl="1">
+            <a:pPr algn="ctr">
               <a:spcAft>
                 <a:spcPts val="400"/>
               </a:spcAft>
@@ -21934,7 +21934,7 @@
               </a:spcAft>
             </a:pPr>
             <a:r>
-              <a:rPr sz="1100" b="0" rtl="1" lang="ar-SA" altLang="en-US">
+              <a:rPr sz="1100" b="0" rtl="0" lang="en-US" altLang="ar-SA">
                 <a:solidFill>
                   <a:srgbClr val="5A5470"/>
                 </a:solidFill>
@@ -22345,7 +22345,7 @@
               </a:spcAft>
             </a:pPr>
             <a:r>
-              <a:rPr sz="1100" b="0" rtl="1" lang="ar-SA" altLang="en-US">
+              <a:rPr sz="1100" b="0" rtl="0" lang="en-US" altLang="ar-SA">
                 <a:solidFill>
                   <a:srgbClr val="5A5470"/>
                 </a:solidFill>
@@ -22386,7 +22386,7 @@
               </a:spcAft>
             </a:pPr>
             <a:r>
-              <a:rPr sz="3200" b="1" rtl="1" lang="ar-SA" altLang="en-US">
+              <a:rPr sz="2800" b="1" rtl="1" lang="ar-SA" altLang="en-US">
                 <a:solidFill>
                   <a:srgbClr val="5234B7"/>
                 </a:solidFill>
@@ -22554,7 +22554,7 @@
           </a:bodyPr>
           <a:lstStyle/>
           <a:p>
-            <a:pPr algn="ctr" rtl="1">
+            <a:pPr algn="ctr">
               <a:spcAft>
                 <a:spcPts val="400"/>
               </a:spcAft>
@@ -22728,7 +22728,7 @@
           </a:bodyPr>
           <a:lstStyle/>
           <a:p>
-            <a:pPr algn="ctr" rtl="1">
+            <a:pPr algn="ctr">
               <a:spcAft>
                 <a:spcPts val="400"/>
               </a:spcAft>
@@ -22902,7 +22902,7 @@
           </a:bodyPr>
           <a:lstStyle/>
           <a:p>
-            <a:pPr algn="ctr" rtl="1">
+            <a:pPr algn="ctr">
               <a:spcAft>
                 <a:spcPts val="400"/>
               </a:spcAft>
@@ -23076,7 +23076,7 @@
           </a:bodyPr>
           <a:lstStyle/>
           <a:p>
-            <a:pPr algn="ctr" rtl="1">
+            <a:pPr algn="ctr">
               <a:spcAft>
                 <a:spcPts val="400"/>
               </a:spcAft>
@@ -23879,7 +23879,7 @@
               </a:spcAft>
             </a:pPr>
             <a:r>
-              <a:rPr sz="1100" b="0" rtl="1" lang="ar-SA" altLang="en-US">
+              <a:rPr sz="1100" b="0" rtl="0" lang="en-US" altLang="ar-SA">
                 <a:solidFill>
                   <a:srgbClr val="5A5470"/>
                 </a:solidFill>
@@ -24184,7 +24184,7 @@
               </a:spcAft>
             </a:pPr>
             <a:r>
-              <a:rPr sz="1100" b="0" rtl="1" lang="ar-SA" altLang="en-US">
+              <a:rPr sz="1100" b="0" rtl="0" lang="en-US" altLang="ar-SA">
                 <a:solidFill>
                   <a:srgbClr val="5A5470"/>
                 </a:solidFill>
@@ -24595,7 +24595,7 @@
               </a:spcAft>
             </a:pPr>
             <a:r>
-              <a:rPr sz="1100" b="0" rtl="1" lang="ar-SA" altLang="en-US">
+              <a:rPr sz="1100" b="0" rtl="0" lang="en-US" altLang="ar-SA">
                 <a:solidFill>
                   <a:srgbClr val="5A5470"/>
                 </a:solidFill>
@@ -24616,8 +24616,8 @@
         </p:nvSpPr>
         <p:spPr>
           <a:xfrm>
-            <a:off x="548640" y="1024128"/>
-            <a:ext cx="6400800" cy="640080"/>
+            <a:off x="5349240" y="1024128"/>
+            <a:ext cx="6217920" cy="640080"/>
           </a:xfrm>
           <a:prstGeom prst="rect">
             <a:avLst/>
@@ -24636,7 +24636,7 @@
               </a:spcAft>
             </a:pPr>
             <a:r>
-              <a:rPr sz="3200" b="1" rtl="1" lang="ar-SA" altLang="en-US">
+              <a:rPr sz="2800" b="1" rtl="1" lang="ar-SA" altLang="en-US">
                 <a:solidFill>
                   <a:srgbClr val="5234B7"/>
                 </a:solidFill>
@@ -24703,8 +24703,8 @@
         </p:nvSpPr>
         <p:spPr>
           <a:xfrm>
-            <a:off x="5623560" y="2377440"/>
-            <a:ext cx="5669280" cy="365760"/>
+            <a:off x="5669280" y="2377440"/>
+            <a:ext cx="5577840" cy="365760"/>
           </a:xfrm>
           <a:prstGeom prst="rect">
             <a:avLst/>
@@ -24744,8 +24744,8 @@
         </p:nvSpPr>
         <p:spPr>
           <a:xfrm>
-            <a:off x="5623560" y="2880360"/>
-            <a:ext cx="5669280" cy="2377440"/>
+            <a:off x="5669280" y="2880360"/>
+            <a:ext cx="5577840" cy="2377440"/>
           </a:xfrm>
           <a:prstGeom prst="rect">
             <a:avLst/>
@@ -25139,7 +25139,7 @@
               </a:spcAft>
             </a:pPr>
             <a:r>
-              <a:rPr sz="1100" b="0" rtl="1" lang="ar-SA" altLang="en-US">
+              <a:rPr sz="1100" b="0" rtl="0" lang="en-US" altLang="ar-SA">
                 <a:solidFill>
                   <a:srgbClr val="5A5470"/>
                 </a:solidFill>
@@ -25307,7 +25307,7 @@
           </a:bodyPr>
           <a:lstStyle/>
           <a:p>
-            <a:pPr algn="ctr" rtl="1">
+            <a:pPr algn="ctr">
               <a:spcAft>
                 <a:spcPts val="400"/>
               </a:spcAft>
@@ -25481,7 +25481,7 @@
           </a:bodyPr>
           <a:lstStyle/>
           <a:p>
-            <a:pPr algn="ctr" rtl="1">
+            <a:pPr algn="ctr">
               <a:spcAft>
                 <a:spcPts val="400"/>
               </a:spcAft>
@@ -25655,7 +25655,7 @@
           </a:bodyPr>
           <a:lstStyle/>
           <a:p>
-            <a:pPr algn="ctr" rtl="1">
+            <a:pPr algn="ctr">
               <a:spcAft>
                 <a:spcPts val="400"/>
               </a:spcAft>
@@ -25829,7 +25829,7 @@
           </a:bodyPr>
           <a:lstStyle/>
           <a:p>
-            <a:pPr algn="ctr" rtl="1">
+            <a:pPr algn="ctr">
               <a:spcAft>
                 <a:spcPts val="400"/>
               </a:spcAft>
@@ -26181,7 +26181,7 @@
               </a:spcAft>
             </a:pPr>
             <a:r>
-              <a:rPr sz="1100" b="0" rtl="1" lang="ar-SA" altLang="en-US">
+              <a:rPr sz="1100" b="0" rtl="0" lang="en-US" altLang="ar-SA">
                 <a:solidFill>
                   <a:srgbClr val="5A5470"/>
                 </a:solidFill>
@@ -26911,7 +26911,7 @@
               </a:spcAft>
             </a:pPr>
             <a:r>
-              <a:rPr sz="1100" b="0" rtl="1" lang="ar-SA" altLang="en-US">
+              <a:rPr sz="1100" b="0" rtl="0" lang="en-US" altLang="ar-SA">
                 <a:solidFill>
                   <a:srgbClr val="5A5470"/>
                 </a:solidFill>
@@ -27101,7 +27101,7 @@
           </a:bodyPr>
           <a:lstStyle/>
           <a:p>
-            <a:pPr algn="ctr" rtl="1">
+            <a:pPr algn="ctr">
               <a:spcAft>
                 <a:spcPts val="600"/>
               </a:spcAft>
@@ -27142,7 +27142,7 @@
           </a:bodyPr>
           <a:lstStyle/>
           <a:p>
-            <a:pPr algn="ctr" rtl="1">
+            <a:pPr algn="ctr">
               <a:spcAft>
                 <a:spcPts val="400"/>
               </a:spcAft>
@@ -27297,7 +27297,7 @@
           </a:bodyPr>
           <a:lstStyle/>
           <a:p>
-            <a:pPr algn="ctr" rtl="1">
+            <a:pPr algn="ctr">
               <a:spcAft>
                 <a:spcPts val="600"/>
               </a:spcAft>
@@ -27338,7 +27338,7 @@
           </a:bodyPr>
           <a:lstStyle/>
           <a:p>
-            <a:pPr algn="ctr" rtl="1">
+            <a:pPr algn="ctr">
               <a:spcAft>
                 <a:spcPts val="400"/>
               </a:spcAft>
@@ -27493,7 +27493,7 @@
           </a:bodyPr>
           <a:lstStyle/>
           <a:p>
-            <a:pPr algn="ctr" rtl="1">
+            <a:pPr algn="ctr">
               <a:spcAft>
                 <a:spcPts val="600"/>
               </a:spcAft>
@@ -27534,7 +27534,7 @@
           </a:bodyPr>
           <a:lstStyle/>
           <a:p>
-            <a:pPr algn="ctr" rtl="1">
+            <a:pPr algn="ctr">
               <a:spcAft>
                 <a:spcPts val="400"/>
               </a:spcAft>
@@ -27845,7 +27845,7 @@
               </a:spcAft>
             </a:pPr>
             <a:r>
-              <a:rPr sz="1100" b="0" rtl="1" lang="ar-SA" altLang="en-US">
+              <a:rPr sz="1100" b="0" rtl="0" lang="en-US" altLang="ar-SA">
                 <a:solidFill>
                   <a:srgbClr val="5A5470"/>
                 </a:solidFill>
@@ -28256,7 +28256,7 @@
               </a:spcAft>
             </a:pPr>
             <a:r>
-              <a:rPr sz="1100" b="0" rtl="1" lang="ar-SA" altLang="en-US">
+              <a:rPr sz="1100" b="0" rtl="0" lang="en-US" altLang="ar-SA">
                 <a:solidFill>
                   <a:srgbClr val="5A5470"/>
                 </a:solidFill>
@@ -28465,7 +28465,7 @@
           </a:bodyPr>
           <a:lstStyle/>
           <a:p>
-            <a:pPr algn="ctr" rtl="1">
+            <a:pPr algn="ctr">
               <a:spcAft>
                 <a:spcPts val="400"/>
               </a:spcAft>
@@ -28639,7 +28639,7 @@
           </a:bodyPr>
           <a:lstStyle/>
           <a:p>
-            <a:pPr algn="ctr" rtl="1">
+            <a:pPr algn="ctr">
               <a:spcAft>
                 <a:spcPts val="400"/>
               </a:spcAft>
@@ -28813,7 +28813,7 @@
           </a:bodyPr>
           <a:lstStyle/>
           <a:p>
-            <a:pPr algn="ctr" rtl="1">
+            <a:pPr algn="ctr">
               <a:spcAft>
                 <a:spcPts val="400"/>
               </a:spcAft>
@@ -28987,7 +28987,7 @@
           </a:bodyPr>
           <a:lstStyle/>
           <a:p>
-            <a:pPr algn="ctr" rtl="1">
+            <a:pPr algn="ctr">
               <a:spcAft>
                 <a:spcPts val="400"/>
               </a:spcAft>
@@ -29161,7 +29161,7 @@
           </a:bodyPr>
           <a:lstStyle/>
           <a:p>
-            <a:pPr algn="ctr" rtl="1">
+            <a:pPr algn="ctr">
               <a:spcAft>
                 <a:spcPts val="400"/>
               </a:spcAft>
@@ -29964,7 +29964,7 @@
               </a:spcAft>
             </a:pPr>
             <a:r>
-              <a:rPr sz="1100" b="0" rtl="1" lang="ar-SA" altLang="en-US">
+              <a:rPr sz="1100" b="0" rtl="0" lang="en-US" altLang="ar-SA">
                 <a:solidFill>
                   <a:srgbClr val="5A5470"/>
                 </a:solidFill>
@@ -30269,7 +30269,7 @@
               </a:spcAft>
             </a:pPr>
             <a:r>
-              <a:rPr sz="1100" b="0" rtl="1" lang="ar-SA" altLang="en-US">
+              <a:rPr sz="1100" b="0" rtl="0" lang="en-US" altLang="ar-SA">
                 <a:solidFill>
                   <a:srgbClr val="5A5470"/>
                 </a:solidFill>
@@ -31040,7 +31040,7 @@
               </a:spcAft>
             </a:pPr>
             <a:r>
-              <a:rPr sz="1100" b="0" rtl="1" lang="ar-SA" altLang="en-US">
+              <a:rPr sz="1100" b="0" rtl="0" lang="en-US" altLang="ar-SA">
                 <a:solidFill>
                   <a:srgbClr val="5A5470"/>
                 </a:solidFill>
@@ -31061,8 +31061,8 @@
         </p:nvSpPr>
         <p:spPr>
           <a:xfrm>
-            <a:off x="548640" y="1024128"/>
-            <a:ext cx="6400800" cy="640080"/>
+            <a:off x="5349240" y="1024128"/>
+            <a:ext cx="6217920" cy="640080"/>
           </a:xfrm>
           <a:prstGeom prst="rect">
             <a:avLst/>
@@ -31081,7 +31081,7 @@
               </a:spcAft>
             </a:pPr>
             <a:r>
-              <a:rPr sz="3200" b="1" rtl="1" lang="ar-SA" altLang="en-US">
+              <a:rPr sz="2600" b="1" rtl="1" lang="ar-SA" altLang="en-US">
                 <a:solidFill>
                   <a:srgbClr val="5234B7"/>
                 </a:solidFill>
@@ -31148,8 +31148,8 @@
         </p:nvSpPr>
         <p:spPr>
           <a:xfrm>
-            <a:off x="5623560" y="2377440"/>
-            <a:ext cx="5669280" cy="365760"/>
+            <a:off x="5669280" y="2377440"/>
+            <a:ext cx="5577840" cy="365760"/>
           </a:xfrm>
           <a:prstGeom prst="rect">
             <a:avLst/>
@@ -31189,8 +31189,8 @@
         </p:nvSpPr>
         <p:spPr>
           <a:xfrm>
-            <a:off x="5623560" y="2880360"/>
-            <a:ext cx="5669280" cy="2377440"/>
+            <a:off x="5669280" y="2880360"/>
+            <a:ext cx="5577840" cy="2377440"/>
           </a:xfrm>
           <a:prstGeom prst="rect">
             <a:avLst/>
@@ -31584,7 +31584,7 @@
               </a:spcAft>
             </a:pPr>
             <a:r>
-              <a:rPr sz="1100" b="0" rtl="1" lang="ar-SA" altLang="en-US">
+              <a:rPr sz="1100" b="0" rtl="0" lang="en-US" altLang="ar-SA">
                 <a:solidFill>
                   <a:srgbClr val="5A5470"/>
                 </a:solidFill>
@@ -31752,7 +31752,7 @@
           </a:bodyPr>
           <a:lstStyle/>
           <a:p>
-            <a:pPr algn="ctr" rtl="1">
+            <a:pPr algn="ctr">
               <a:spcAft>
                 <a:spcPts val="400"/>
               </a:spcAft>
@@ -31926,7 +31926,7 @@
           </a:bodyPr>
           <a:lstStyle/>
           <a:p>
-            <a:pPr algn="ctr" rtl="1">
+            <a:pPr algn="ctr">
               <a:spcAft>
                 <a:spcPts val="400"/>
               </a:spcAft>
@@ -32100,7 +32100,7 @@
           </a:bodyPr>
           <a:lstStyle/>
           <a:p>
-            <a:pPr algn="ctr" rtl="1">
+            <a:pPr algn="ctr">
               <a:spcAft>
                 <a:spcPts val="400"/>
               </a:spcAft>
@@ -32274,7 +32274,7 @@
           </a:bodyPr>
           <a:lstStyle/>
           <a:p>
-            <a:pPr algn="ctr" rtl="1">
+            <a:pPr algn="ctr">
               <a:spcAft>
                 <a:spcPts val="400"/>
               </a:spcAft>
@@ -32626,7 +32626,7 @@
               </a:spcAft>
             </a:pPr>
             <a:r>
-              <a:rPr sz="1100" b="0" rtl="1" lang="ar-SA" altLang="en-US">
+              <a:rPr sz="1100" b="0" rtl="0" lang="en-US" altLang="ar-SA">
                 <a:solidFill>
                   <a:srgbClr val="5A5470"/>
                 </a:solidFill>
@@ -32816,7 +32816,7 @@
           </a:bodyPr>
           <a:lstStyle/>
           <a:p>
-            <a:pPr algn="ctr" rtl="1">
+            <a:pPr algn="ctr">
               <a:spcAft>
                 <a:spcPts val="600"/>
               </a:spcAft>
@@ -32857,7 +32857,7 @@
           </a:bodyPr>
           <a:lstStyle/>
           <a:p>
-            <a:pPr algn="ctr" rtl="1">
+            <a:pPr algn="ctr">
               <a:spcAft>
                 <a:spcPts val="400"/>
               </a:spcAft>
@@ -33012,7 +33012,7 @@
           </a:bodyPr>
           <a:lstStyle/>
           <a:p>
-            <a:pPr algn="ctr" rtl="1">
+            <a:pPr algn="ctr">
               <a:spcAft>
                 <a:spcPts val="600"/>
               </a:spcAft>
@@ -33053,7 +33053,7 @@
           </a:bodyPr>
           <a:lstStyle/>
           <a:p>
-            <a:pPr algn="ctr" rtl="1">
+            <a:pPr algn="ctr">
               <a:spcAft>
                 <a:spcPts val="400"/>
               </a:spcAft>
@@ -33364,7 +33364,7 @@
               </a:spcAft>
             </a:pPr>
             <a:r>
-              <a:rPr sz="1100" b="0" rtl="1" lang="ar-SA" altLang="en-US">
+              <a:rPr sz="1100" b="0" rtl="0" lang="en-US" altLang="ar-SA">
                 <a:solidFill>
                   <a:srgbClr val="5A5470"/>
                 </a:solidFill>
@@ -33573,7 +33573,7 @@
           </a:bodyPr>
           <a:lstStyle/>
           <a:p>
-            <a:pPr algn="ctr" rtl="1">
+            <a:pPr algn="ctr">
               <a:spcAft>
                 <a:spcPts val="400"/>
               </a:spcAft>
@@ -33701,7 +33701,7 @@
           </a:bodyPr>
           <a:lstStyle/>
           <a:p>
-            <a:pPr algn="ctr" rtl="1">
+            <a:pPr algn="ctr">
               <a:spcAft>
                 <a:spcPts val="400"/>
               </a:spcAft>
@@ -33875,7 +33875,7 @@
           </a:bodyPr>
           <a:lstStyle/>
           <a:p>
-            <a:pPr algn="ctr" rtl="1">
+            <a:pPr algn="ctr">
               <a:spcAft>
                 <a:spcPts val="400"/>
               </a:spcAft>
@@ -34003,7 +34003,7 @@
           </a:bodyPr>
           <a:lstStyle/>
           <a:p>
-            <a:pPr algn="ctr" rtl="1">
+            <a:pPr algn="ctr">
               <a:spcAft>
                 <a:spcPts val="400"/>
               </a:spcAft>
@@ -34177,7 +34177,7 @@
           </a:bodyPr>
           <a:lstStyle/>
           <a:p>
-            <a:pPr algn="ctr" rtl="1">
+            <a:pPr algn="ctr">
               <a:spcAft>
                 <a:spcPts val="400"/>
               </a:spcAft>
@@ -34529,7 +34529,7 @@
               </a:spcAft>
             </a:pPr>
             <a:r>
-              <a:rPr sz="1100" b="0" rtl="1" lang="ar-SA" altLang="en-US">
+              <a:rPr sz="1100" b="0" rtl="0" lang="en-US" altLang="ar-SA">
                 <a:solidFill>
                   <a:srgbClr val="5A5470"/>
                 </a:solidFill>
@@ -34550,8 +34550,8 @@
         </p:nvSpPr>
         <p:spPr>
           <a:xfrm>
-            <a:off x="548640" y="1024128"/>
-            <a:ext cx="6400800" cy="640080"/>
+            <a:off x="5349240" y="1024128"/>
+            <a:ext cx="6217920" cy="640080"/>
           </a:xfrm>
           <a:prstGeom prst="rect">
             <a:avLst/>
@@ -34570,7 +34570,7 @@
               </a:spcAft>
             </a:pPr>
             <a:r>
-              <a:rPr sz="2800" b="1" rtl="1" lang="ar-SA" altLang="en-US">
+              <a:rPr sz="2600" b="1" rtl="1" lang="ar-SA" altLang="en-US">
                 <a:solidFill>
                   <a:srgbClr val="5234B7"/>
                 </a:solidFill>
@@ -34637,8 +34637,8 @@
         </p:nvSpPr>
         <p:spPr>
           <a:xfrm>
-            <a:off x="5623560" y="2377440"/>
-            <a:ext cx="5669280" cy="365760"/>
+            <a:off x="5669280" y="2377440"/>
+            <a:ext cx="5577840" cy="365760"/>
           </a:xfrm>
           <a:prstGeom prst="rect">
             <a:avLst/>
@@ -34678,8 +34678,8 @@
         </p:nvSpPr>
         <p:spPr>
           <a:xfrm>
-            <a:off x="5623560" y="2880360"/>
-            <a:ext cx="5669280" cy="2377440"/>
+            <a:off x="5669280" y="2880360"/>
+            <a:ext cx="5577840" cy="2377440"/>
           </a:xfrm>
           <a:prstGeom prst="rect">
             <a:avLst/>
@@ -35073,7 +35073,7 @@
               </a:spcAft>
             </a:pPr>
             <a:r>
-              <a:rPr sz="1100" b="0" rtl="1" lang="ar-SA" altLang="en-US">
+              <a:rPr sz="1100" b="0" rtl="0" lang="en-US" altLang="ar-SA">
                 <a:solidFill>
                   <a:srgbClr val="5A5470"/>
                 </a:solidFill>
@@ -35803,7 +35803,7 @@
               </a:spcAft>
             </a:pPr>
             <a:r>
-              <a:rPr sz="1100" b="0" rtl="1" lang="ar-SA" altLang="en-US">
+              <a:rPr sz="1100" b="0" rtl="0" lang="en-US" altLang="ar-SA">
                 <a:solidFill>
                   <a:srgbClr val="5A5470"/>
                 </a:solidFill>
@@ -35993,7 +35993,7 @@
           </a:bodyPr>
           <a:lstStyle/>
           <a:p>
-            <a:pPr algn="ctr" rtl="1">
+            <a:pPr algn="ctr">
               <a:spcAft>
                 <a:spcPts val="600"/>
               </a:spcAft>
@@ -36034,7 +36034,7 @@
           </a:bodyPr>
           <a:lstStyle/>
           <a:p>
-            <a:pPr algn="ctr" rtl="1">
+            <a:pPr algn="ctr">
               <a:spcAft>
                 <a:spcPts val="400"/>
               </a:spcAft>
@@ -36189,7 +36189,7 @@
           </a:bodyPr>
           <a:lstStyle/>
           <a:p>
-            <a:pPr algn="ctr" rtl="1">
+            <a:pPr algn="ctr">
               <a:spcAft>
                 <a:spcPts val="600"/>
               </a:spcAft>
@@ -36230,7 +36230,7 @@
           </a:bodyPr>
           <a:lstStyle/>
           <a:p>
-            <a:pPr algn="ctr" rtl="1">
+            <a:pPr algn="ctr">
               <a:spcAft>
                 <a:spcPts val="400"/>
               </a:spcAft>
@@ -36385,7 +36385,7 @@
           </a:bodyPr>
           <a:lstStyle/>
           <a:p>
-            <a:pPr algn="ctr" rtl="1">
+            <a:pPr algn="ctr">
               <a:spcAft>
                 <a:spcPts val="600"/>
               </a:spcAft>
@@ -36426,7 +36426,7 @@
           </a:bodyPr>
           <a:lstStyle/>
           <a:p>
-            <a:pPr algn="ctr" rtl="1">
+            <a:pPr algn="ctr">
               <a:spcAft>
                 <a:spcPts val="400"/>
               </a:spcAft>
@@ -36737,7 +36737,7 @@
               </a:spcAft>
             </a:pPr>
             <a:r>
-              <a:rPr sz="1100" b="0" rtl="1" lang="ar-SA" altLang="en-US">
+              <a:rPr sz="1100" b="0" rtl="0" lang="en-US" altLang="ar-SA">
                 <a:solidFill>
                   <a:srgbClr val="5A5470"/>
                 </a:solidFill>
@@ -37148,7 +37148,7 @@
               </a:spcAft>
             </a:pPr>
             <a:r>
-              <a:rPr sz="1100" b="0" rtl="1" lang="ar-SA" altLang="en-US">
+              <a:rPr sz="1100" b="0" rtl="0" lang="en-US" altLang="ar-SA">
                 <a:solidFill>
                   <a:srgbClr val="5A5470"/>
                 </a:solidFill>
@@ -37357,7 +37357,7 @@
           </a:bodyPr>
           <a:lstStyle/>
           <a:p>
-            <a:pPr algn="ctr" rtl="1">
+            <a:pPr algn="ctr">
               <a:spcAft>
                 <a:spcPts val="400"/>
               </a:spcAft>
@@ -37531,7 +37531,7 @@
           </a:bodyPr>
           <a:lstStyle/>
           <a:p>
-            <a:pPr algn="ctr" rtl="1">
+            <a:pPr algn="ctr">
               <a:spcAft>
                 <a:spcPts val="400"/>
               </a:spcAft>
@@ -37705,7 +37705,7 @@
           </a:bodyPr>
           <a:lstStyle/>
           <a:p>
-            <a:pPr algn="ctr" rtl="1">
+            <a:pPr algn="ctr">
               <a:spcAft>
                 <a:spcPts val="400"/>
               </a:spcAft>
@@ -37879,7 +37879,7 @@
           </a:bodyPr>
           <a:lstStyle/>
           <a:p>
-            <a:pPr algn="ctr" rtl="1">
+            <a:pPr algn="ctr">
               <a:spcAft>
                 <a:spcPts val="400"/>
               </a:spcAft>
@@ -38231,7 +38231,7 @@
               </a:spcAft>
             </a:pPr>
             <a:r>
-              <a:rPr sz="1100" b="0" rtl="1" lang="ar-SA" altLang="en-US">
+              <a:rPr sz="1100" b="0" rtl="0" lang="en-US" altLang="ar-SA">
                 <a:solidFill>
                   <a:srgbClr val="5A5470"/>
                 </a:solidFill>
@@ -38252,8 +38252,8 @@
         </p:nvSpPr>
         <p:spPr>
           <a:xfrm>
-            <a:off x="548640" y="1024128"/>
-            <a:ext cx="6400800" cy="640080"/>
+            <a:off x="5349240" y="1024128"/>
+            <a:ext cx="6217920" cy="640080"/>
           </a:xfrm>
           <a:prstGeom prst="rect">
             <a:avLst/>
@@ -38339,8 +38339,8 @@
         </p:nvSpPr>
         <p:spPr>
           <a:xfrm>
-            <a:off x="5623560" y="2377440"/>
-            <a:ext cx="5669280" cy="365760"/>
+            <a:off x="5669280" y="2377440"/>
+            <a:ext cx="5577840" cy="365760"/>
           </a:xfrm>
           <a:prstGeom prst="rect">
             <a:avLst/>
@@ -38380,8 +38380,8 @@
         </p:nvSpPr>
         <p:spPr>
           <a:xfrm>
-            <a:off x="5623560" y="2880360"/>
-            <a:ext cx="5669280" cy="2377440"/>
+            <a:off x="5669280" y="2880360"/>
+            <a:ext cx="5577840" cy="2377440"/>
           </a:xfrm>
           <a:prstGeom prst="rect">
             <a:avLst/>
@@ -38775,7 +38775,7 @@
               </a:spcAft>
             </a:pPr>
             <a:r>
-              <a:rPr sz="1100" b="0" rtl="1" lang="ar-SA" altLang="en-US">
+              <a:rPr sz="1100" b="0" rtl="0" lang="en-US" altLang="ar-SA">
                 <a:solidFill>
                   <a:srgbClr val="5A5470"/>
                 </a:solidFill>
@@ -38943,7 +38943,7 @@
           </a:bodyPr>
           <a:lstStyle/>
           <a:p>
-            <a:pPr algn="ctr" rtl="1">
+            <a:pPr algn="ctr">
               <a:spcAft>
                 <a:spcPts val="400"/>
               </a:spcAft>
@@ -39117,7 +39117,7 @@
           </a:bodyPr>
           <a:lstStyle/>
           <a:p>
-            <a:pPr algn="ctr" rtl="1">
+            <a:pPr algn="ctr">
               <a:spcAft>
                 <a:spcPts val="400"/>
               </a:spcAft>
@@ -39291,7 +39291,7 @@
           </a:bodyPr>
           <a:lstStyle/>
           <a:p>
-            <a:pPr algn="ctr" rtl="1">
+            <a:pPr algn="ctr">
               <a:spcAft>
                 <a:spcPts val="400"/>
               </a:spcAft>
@@ -39465,7 +39465,7 @@
           </a:bodyPr>
           <a:lstStyle/>
           <a:p>
-            <a:pPr algn="ctr" rtl="1">
+            <a:pPr algn="ctr">
               <a:spcAft>
                 <a:spcPts val="400"/>
               </a:spcAft>
@@ -39639,7 +39639,7 @@
           </a:bodyPr>
           <a:lstStyle/>
           <a:p>
-            <a:pPr algn="ctr" rtl="1">
+            <a:pPr algn="ctr">
               <a:spcAft>
                 <a:spcPts val="400"/>
               </a:spcAft>
@@ -39991,7 +39991,7 @@
               </a:spcAft>
             </a:pPr>
             <a:r>
-              <a:rPr sz="1100" b="0" rtl="1" lang="ar-SA" altLang="en-US">
+              <a:rPr sz="1100" b="0" rtl="0" lang="en-US" altLang="ar-SA">
                 <a:solidFill>
                   <a:srgbClr val="5A5470"/>
                 </a:solidFill>
@@ -40402,7 +40402,7 @@
               </a:spcAft>
             </a:pPr>
             <a:r>
-              <a:rPr sz="1100" b="0" rtl="1" lang="ar-SA" altLang="en-US">
+              <a:rPr sz="1100" b="0" rtl="0" lang="en-US" altLang="ar-SA">
                 <a:solidFill>
                   <a:srgbClr val="5A5470"/>
                 </a:solidFill>
@@ -40570,7 +40570,7 @@
           </a:bodyPr>
           <a:lstStyle/>
           <a:p>
-            <a:pPr algn="ctr" rtl="1">
+            <a:pPr algn="ctr">
               <a:spcAft>
                 <a:spcPts val="400"/>
               </a:spcAft>
@@ -40744,7 +40744,7 @@
           </a:bodyPr>
           <a:lstStyle/>
           <a:p>
-            <a:pPr algn="ctr" rtl="1">
+            <a:pPr algn="ctr">
               <a:spcAft>
                 <a:spcPts val="400"/>
               </a:spcAft>
@@ -40918,7 +40918,7 @@
           </a:bodyPr>
           <a:lstStyle/>
           <a:p>
-            <a:pPr algn="ctr" rtl="1">
+            <a:pPr algn="ctr">
               <a:spcAft>
                 <a:spcPts val="400"/>
               </a:spcAft>
@@ -41092,7 +41092,7 @@
           </a:bodyPr>
           <a:lstStyle/>
           <a:p>
-            <a:pPr algn="ctr" rtl="1">
+            <a:pPr algn="ctr">
               <a:spcAft>
                 <a:spcPts val="400"/>
               </a:spcAft>
@@ -41444,7 +41444,7 @@
               </a:spcAft>
             </a:pPr>
             <a:r>
-              <a:rPr sz="1100" b="0" rtl="1" lang="ar-SA" altLang="en-US">
+              <a:rPr sz="1100" b="0" rtl="0" lang="en-US" altLang="ar-SA">
                 <a:solidFill>
                   <a:srgbClr val="5A5470"/>
                 </a:solidFill>
@@ -42215,7 +42215,7 @@
               </a:spcAft>
             </a:pPr>
             <a:r>
-              <a:rPr sz="1100" b="0" rtl="1" lang="ar-SA" altLang="en-US">
+              <a:rPr sz="1100" b="0" rtl="0" lang="en-US" altLang="ar-SA">
                 <a:solidFill>
                   <a:srgbClr val="5A5470"/>
                 </a:solidFill>
@@ -42424,7 +42424,7 @@
           </a:bodyPr>
           <a:lstStyle/>
           <a:p>
-            <a:pPr algn="ctr" rtl="1">
+            <a:pPr algn="ctr">
               <a:spcAft>
                 <a:spcPts val="400"/>
               </a:spcAft>
@@ -42598,7 +42598,7 @@
           </a:bodyPr>
           <a:lstStyle/>
           <a:p>
-            <a:pPr algn="ctr" rtl="1">
+            <a:pPr algn="ctr">
               <a:spcAft>
                 <a:spcPts val="400"/>
               </a:spcAft>
@@ -42772,7 +42772,7 @@
           </a:bodyPr>
           <a:lstStyle/>
           <a:p>
-            <a:pPr algn="ctr" rtl="1">
+            <a:pPr algn="ctr">
               <a:spcAft>
                 <a:spcPts val="400"/>
               </a:spcAft>
@@ -42946,7 +42946,7 @@
           </a:bodyPr>
           <a:lstStyle/>
           <a:p>
-            <a:pPr algn="ctr" rtl="1">
+            <a:pPr algn="ctr">
               <a:spcAft>
                 <a:spcPts val="400"/>
               </a:spcAft>
@@ -43298,7 +43298,7 @@
               </a:spcAft>
             </a:pPr>
             <a:r>
-              <a:rPr sz="1100" b="0" rtl="1" lang="ar-SA" altLang="en-US">
+              <a:rPr sz="1100" b="0" rtl="0" lang="en-US" altLang="ar-SA">
                 <a:solidFill>
                   <a:srgbClr val="5A5470"/>
                 </a:solidFill>
@@ -44520,7 +44520,7 @@
               </a:spcAft>
             </a:pPr>
             <a:r>
-              <a:rPr sz="1100" b="0" rtl="1" lang="ar-SA" altLang="en-US">
+              <a:rPr sz="1100" b="0" rtl="0" lang="en-US" altLang="ar-SA">
                 <a:solidFill>
                   <a:srgbClr val="5A5470"/>
                 </a:solidFill>
@@ -44825,7 +44825,7 @@
               </a:spcAft>
             </a:pPr>
             <a:r>
-              <a:rPr sz="1100" b="0" rtl="1" lang="ar-SA" altLang="en-US">
+              <a:rPr sz="1100" b="0" rtl="0" lang="en-US" altLang="ar-SA">
                 <a:solidFill>
                   <a:srgbClr val="5A5470"/>
                 </a:solidFill>
@@ -44846,8 +44846,8 @@
         </p:nvSpPr>
         <p:spPr>
           <a:xfrm>
-            <a:off x="548640" y="1024128"/>
-            <a:ext cx="6400800" cy="640080"/>
+            <a:off x="5349240" y="1024128"/>
+            <a:ext cx="6217920" cy="640080"/>
           </a:xfrm>
           <a:prstGeom prst="rect">
             <a:avLst/>
@@ -44866,7 +44866,7 @@
               </a:spcAft>
             </a:pPr>
             <a:r>
-              <a:rPr sz="3200" b="1" rtl="1" lang="ar-SA" altLang="en-US">
+              <a:rPr sz="2600" b="1" rtl="1" lang="ar-SA" altLang="en-US">
                 <a:solidFill>
                   <a:srgbClr val="5234B7"/>
                 </a:solidFill>
@@ -44933,8 +44933,8 @@
         </p:nvSpPr>
         <p:spPr>
           <a:xfrm>
-            <a:off x="5623560" y="2377440"/>
-            <a:ext cx="5669280" cy="365760"/>
+            <a:off x="5669280" y="2377440"/>
+            <a:ext cx="5577840" cy="365760"/>
           </a:xfrm>
           <a:prstGeom prst="rect">
             <a:avLst/>
@@ -44974,8 +44974,8 @@
         </p:nvSpPr>
         <p:spPr>
           <a:xfrm>
-            <a:off x="5623560" y="2880360"/>
-            <a:ext cx="5669280" cy="2377440"/>
+            <a:off x="5669280" y="2880360"/>
+            <a:ext cx="5577840" cy="2377440"/>
           </a:xfrm>
           <a:prstGeom prst="rect">
             <a:avLst/>
@@ -45369,7 +45369,7 @@
               </a:spcAft>
             </a:pPr>
             <a:r>
-              <a:rPr sz="1100" b="0" rtl="1" lang="ar-SA" altLang="en-US">
+              <a:rPr sz="1100" b="0" rtl="0" lang="en-US" altLang="ar-SA">
                 <a:solidFill>
                   <a:srgbClr val="5A5470"/>
                 </a:solidFill>
@@ -45780,7 +45780,7 @@
               </a:spcAft>
             </a:pPr>
             <a:r>
-              <a:rPr sz="1100" b="0" rtl="1" lang="ar-SA" altLang="en-US">
+              <a:rPr sz="1100" b="0" rtl="0" lang="en-US" altLang="ar-SA">
                 <a:solidFill>
                   <a:srgbClr val="5A5470"/>
                 </a:solidFill>
@@ -45948,7 +45948,7 @@
           </a:bodyPr>
           <a:lstStyle/>
           <a:p>
-            <a:pPr algn="ctr" rtl="1">
+            <a:pPr algn="ctr">
               <a:spcAft>
                 <a:spcPts val="400"/>
               </a:spcAft>
@@ -46122,7 +46122,7 @@
           </a:bodyPr>
           <a:lstStyle/>
           <a:p>
-            <a:pPr algn="ctr" rtl="1">
+            <a:pPr algn="ctr">
               <a:spcAft>
                 <a:spcPts val="400"/>
               </a:spcAft>
@@ -46296,7 +46296,7 @@
           </a:bodyPr>
           <a:lstStyle/>
           <a:p>
-            <a:pPr algn="ctr" rtl="1">
+            <a:pPr algn="ctr">
               <a:spcAft>
                 <a:spcPts val="400"/>
               </a:spcAft>
@@ -46470,7 +46470,7 @@
           </a:bodyPr>
           <a:lstStyle/>
           <a:p>
-            <a:pPr algn="ctr" rtl="1">
+            <a:pPr algn="ctr">
               <a:spcAft>
                 <a:spcPts val="400"/>
               </a:spcAft>
@@ -46822,7 +46822,7 @@
               </a:spcAft>
             </a:pPr>
             <a:r>
-              <a:rPr sz="1100" b="0" rtl="1" lang="ar-SA" altLang="en-US">
+              <a:rPr sz="1100" b="0" rtl="0" lang="en-US" altLang="ar-SA">
                 <a:solidFill>
                   <a:srgbClr val="5A5470"/>
                 </a:solidFill>
@@ -47593,7 +47593,7 @@
               </a:spcAft>
             </a:pPr>
             <a:r>
-              <a:rPr sz="1100" b="0" rtl="1" lang="ar-SA" altLang="en-US">
+              <a:rPr sz="1100" b="0" rtl="0" lang="en-US" altLang="ar-SA">
                 <a:solidFill>
                   <a:srgbClr val="5A5470"/>
                 </a:solidFill>
@@ -47783,7 +47783,7 @@
           </a:bodyPr>
           <a:lstStyle/>
           <a:p>
-            <a:pPr algn="ctr" rtl="1">
+            <a:pPr algn="ctr">
               <a:spcAft>
                 <a:spcPts val="600"/>
               </a:spcAft>
@@ -47824,7 +47824,7 @@
           </a:bodyPr>
           <a:lstStyle/>
           <a:p>
-            <a:pPr algn="ctr" rtl="1">
+            <a:pPr algn="ctr">
               <a:spcAft>
                 <a:spcPts val="400"/>
               </a:spcAft>
@@ -48135,7 +48135,7 @@
               </a:spcAft>
             </a:pPr>
             <a:r>
-              <a:rPr sz="1100" b="0" rtl="1" lang="ar-SA" altLang="en-US">
+              <a:rPr sz="1100" b="0" rtl="0" lang="en-US" altLang="ar-SA">
                 <a:solidFill>
                   <a:srgbClr val="5A5470"/>
                 </a:solidFill>
@@ -48176,7 +48176,7 @@
               </a:spcAft>
             </a:pPr>
             <a:r>
-              <a:rPr sz="3200" b="1" rtl="1" lang="ar-SA" altLang="en-US">
+              <a:rPr sz="2800" b="1" rtl="1" lang="ar-SA" altLang="en-US">
                 <a:solidFill>
                   <a:srgbClr val="5234B7"/>
                 </a:solidFill>
@@ -48344,7 +48344,7 @@
           </a:bodyPr>
           <a:lstStyle/>
           <a:p>
-            <a:pPr algn="ctr" rtl="1">
+            <a:pPr algn="ctr">
               <a:spcAft>
                 <a:spcPts val="400"/>
               </a:spcAft>
@@ -48518,7 +48518,7 @@
           </a:bodyPr>
           <a:lstStyle/>
           <a:p>
-            <a:pPr algn="ctr" rtl="1">
+            <a:pPr algn="ctr">
               <a:spcAft>
                 <a:spcPts val="400"/>
               </a:spcAft>
@@ -48692,7 +48692,7 @@
           </a:bodyPr>
           <a:lstStyle/>
           <a:p>
-            <a:pPr algn="ctr" rtl="1">
+            <a:pPr algn="ctr">
               <a:spcAft>
                 <a:spcPts val="400"/>
               </a:spcAft>
@@ -48866,7 +48866,7 @@
           </a:bodyPr>
           <a:lstStyle/>
           <a:p>
-            <a:pPr algn="ctr" rtl="1">
+            <a:pPr algn="ctr">
               <a:spcAft>
                 <a:spcPts val="400"/>
               </a:spcAft>
@@ -49040,7 +49040,7 @@
           </a:bodyPr>
           <a:lstStyle/>
           <a:p>
-            <a:pPr algn="ctr" rtl="1">
+            <a:pPr algn="ctr">
               <a:spcAft>
                 <a:spcPts val="400"/>
               </a:spcAft>
@@ -49392,7 +49392,7 @@
               </a:spcAft>
             </a:pPr>
             <a:r>
-              <a:rPr sz="1100" b="0" rtl="1" lang="ar-SA" altLang="en-US">
+              <a:rPr sz="1100" b="0" rtl="0" lang="en-US" altLang="ar-SA">
                 <a:solidFill>
                   <a:srgbClr val="5A5470"/>
                 </a:solidFill>
@@ -49413,8 +49413,8 @@
         </p:nvSpPr>
         <p:spPr>
           <a:xfrm>
-            <a:off x="548640" y="1024128"/>
-            <a:ext cx="6400800" cy="640080"/>
+            <a:off x="5349240" y="1024128"/>
+            <a:ext cx="6217920" cy="640080"/>
           </a:xfrm>
           <a:prstGeom prst="rect">
             <a:avLst/>
@@ -49433,7 +49433,7 @@
               </a:spcAft>
             </a:pPr>
             <a:r>
-              <a:rPr sz="3200" b="1" rtl="1" lang="ar-SA" altLang="en-US">
+              <a:rPr sz="2600" b="1" rtl="1" lang="ar-SA" altLang="en-US">
                 <a:solidFill>
                   <a:srgbClr val="5234B7"/>
                 </a:solidFill>
@@ -49500,8 +49500,8 @@
         </p:nvSpPr>
         <p:spPr>
           <a:xfrm>
-            <a:off x="5623560" y="2377440"/>
-            <a:ext cx="5669280" cy="365760"/>
+            <a:off x="5669280" y="2377440"/>
+            <a:ext cx="5577840" cy="365760"/>
           </a:xfrm>
           <a:prstGeom prst="rect">
             <a:avLst/>
@@ -49541,8 +49541,8 @@
         </p:nvSpPr>
         <p:spPr>
           <a:xfrm>
-            <a:off x="5623560" y="2880360"/>
-            <a:ext cx="5669280" cy="2377440"/>
+            <a:off x="5669280" y="2880360"/>
+            <a:ext cx="5577840" cy="2377440"/>
           </a:xfrm>
           <a:prstGeom prst="rect">
             <a:avLst/>
@@ -49936,7 +49936,7 @@
               </a:spcAft>
             </a:pPr>
             <a:r>
-              <a:rPr sz="1100" b="0" rtl="1" lang="ar-SA" altLang="en-US">
+              <a:rPr sz="1100" b="0" rtl="0" lang="en-US" altLang="ar-SA">
                 <a:solidFill>
                   <a:srgbClr val="5A5470"/>
                 </a:solidFill>
@@ -50347,7 +50347,7 @@
               </a:spcAft>
             </a:pPr>
             <a:r>
-              <a:rPr sz="1100" b="0" rtl="1" lang="ar-SA" altLang="en-US">
+              <a:rPr sz="1100" b="0" rtl="0" lang="en-US" altLang="ar-SA">
                 <a:solidFill>
                   <a:srgbClr val="5A5470"/>
                 </a:solidFill>
@@ -50515,7 +50515,7 @@
           </a:bodyPr>
           <a:lstStyle/>
           <a:p>
-            <a:pPr algn="ctr" rtl="1">
+            <a:pPr algn="ctr">
               <a:spcAft>
                 <a:spcPts val="400"/>
               </a:spcAft>
@@ -50689,7 +50689,7 @@
           </a:bodyPr>
           <a:lstStyle/>
           <a:p>
-            <a:pPr algn="ctr" rtl="1">
+            <a:pPr algn="ctr">
               <a:spcAft>
                 <a:spcPts val="400"/>
               </a:spcAft>
@@ -50863,7 +50863,7 @@
           </a:bodyPr>
           <a:lstStyle/>
           <a:p>
-            <a:pPr algn="ctr" rtl="1">
+            <a:pPr algn="ctr">
               <a:spcAft>
                 <a:spcPts val="400"/>
               </a:spcAft>
@@ -51037,7 +51037,7 @@
           </a:bodyPr>
           <a:lstStyle/>
           <a:p>
-            <a:pPr algn="ctr" rtl="1">
+            <a:pPr algn="ctr">
               <a:spcAft>
                 <a:spcPts val="400"/>
               </a:spcAft>
@@ -51389,7 +51389,7 @@
               </a:spcAft>
             </a:pPr>
             <a:r>
-              <a:rPr sz="1100" b="0" rtl="1" lang="ar-SA" altLang="en-US">
+              <a:rPr sz="1100" b="0" rtl="0" lang="en-US" altLang="ar-SA">
                 <a:solidFill>
                   <a:srgbClr val="5A5470"/>
                 </a:solidFill>
@@ -51579,7 +51579,7 @@
           </a:bodyPr>
           <a:lstStyle/>
           <a:p>
-            <a:pPr algn="ctr" rtl="1">
+            <a:pPr algn="ctr">
               <a:spcAft>
                 <a:spcPts val="600"/>
               </a:spcAft>
@@ -51620,7 +51620,7 @@
           </a:bodyPr>
           <a:lstStyle/>
           <a:p>
-            <a:pPr algn="ctr" rtl="1">
+            <a:pPr algn="ctr">
               <a:spcAft>
                 <a:spcPts val="400"/>
               </a:spcAft>
@@ -51775,7 +51775,7 @@
           </a:bodyPr>
           <a:lstStyle/>
           <a:p>
-            <a:pPr algn="ctr" rtl="1">
+            <a:pPr algn="ctr">
               <a:spcAft>
                 <a:spcPts val="600"/>
               </a:spcAft>
@@ -51816,7 +51816,7 @@
           </a:bodyPr>
           <a:lstStyle/>
           <a:p>
-            <a:pPr algn="ctr" rtl="1">
+            <a:pPr algn="ctr">
               <a:spcAft>
                 <a:spcPts val="400"/>
               </a:spcAft>
@@ -52127,7 +52127,7 @@
               </a:spcAft>
             </a:pPr>
             <a:r>
-              <a:rPr sz="1100" b="0" rtl="1" lang="ar-SA" altLang="en-US">
+              <a:rPr sz="1100" b="0" rtl="0" lang="en-US" altLang="ar-SA">
                 <a:solidFill>
                   <a:srgbClr val="5A5470"/>
                 </a:solidFill>
@@ -52336,7 +52336,7 @@
           </a:bodyPr>
           <a:lstStyle/>
           <a:p>
-            <a:pPr algn="ctr" rtl="1">
+            <a:pPr algn="ctr">
               <a:spcAft>
                 <a:spcPts val="400"/>
               </a:spcAft>
@@ -52464,7 +52464,7 @@
           </a:bodyPr>
           <a:lstStyle/>
           <a:p>
-            <a:pPr algn="ctr" rtl="1">
+            <a:pPr algn="ctr">
               <a:spcAft>
                 <a:spcPts val="400"/>
               </a:spcAft>
@@ -52638,7 +52638,7 @@
           </a:bodyPr>
           <a:lstStyle/>
           <a:p>
-            <a:pPr algn="ctr" rtl="1">
+            <a:pPr algn="ctr">
               <a:spcAft>
                 <a:spcPts val="400"/>
               </a:spcAft>
@@ -52766,7 +52766,7 @@
           </a:bodyPr>
           <a:lstStyle/>
           <a:p>
-            <a:pPr algn="ctr" rtl="1">
+            <a:pPr algn="ctr">
               <a:spcAft>
                 <a:spcPts val="400"/>
               </a:spcAft>
@@ -52940,7 +52940,7 @@
           </a:bodyPr>
           <a:lstStyle/>
           <a:p>
-            <a:pPr algn="ctr" rtl="1">
+            <a:pPr algn="ctr">
               <a:spcAft>
                 <a:spcPts val="400"/>
               </a:spcAft>
@@ -53292,7 +53292,7 @@
               </a:spcAft>
             </a:pPr>
             <a:r>
-              <a:rPr sz="1100" b="0" rtl="1" lang="ar-SA" altLang="en-US">
+              <a:rPr sz="1100" b="0" rtl="0" lang="en-US" altLang="ar-SA">
                 <a:solidFill>
                   <a:srgbClr val="5A5470"/>
                 </a:solidFill>
@@ -53313,8 +53313,8 @@
         </p:nvSpPr>
         <p:spPr>
           <a:xfrm>
-            <a:off x="548640" y="1024128"/>
-            <a:ext cx="6400800" cy="640080"/>
+            <a:off x="5349240" y="1024128"/>
+            <a:ext cx="6217920" cy="640080"/>
           </a:xfrm>
           <a:prstGeom prst="rect">
             <a:avLst/>
@@ -53333,7 +53333,7 @@
               </a:spcAft>
             </a:pPr>
             <a:r>
-              <a:rPr sz="2800" b="1" rtl="1" lang="ar-SA" altLang="en-US">
+              <a:rPr sz="2600" b="1" rtl="1" lang="ar-SA" altLang="en-US">
                 <a:solidFill>
                   <a:srgbClr val="5234B7"/>
                 </a:solidFill>
@@ -53400,8 +53400,8 @@
         </p:nvSpPr>
         <p:spPr>
           <a:xfrm>
-            <a:off x="5623560" y="2377440"/>
-            <a:ext cx="5669280" cy="365760"/>
+            <a:off x="5669280" y="2377440"/>
+            <a:ext cx="5577840" cy="365760"/>
           </a:xfrm>
           <a:prstGeom prst="rect">
             <a:avLst/>
@@ -53441,8 +53441,8 @@
         </p:nvSpPr>
         <p:spPr>
           <a:xfrm>
-            <a:off x="5623560" y="2880360"/>
-            <a:ext cx="5669280" cy="2377440"/>
+            <a:off x="5669280" y="2880360"/>
+            <a:ext cx="5577840" cy="2377440"/>
           </a:xfrm>
           <a:prstGeom prst="rect">
             <a:avLst/>
@@ -53836,7 +53836,7 @@
               </a:spcAft>
             </a:pPr>
             <a:r>
-              <a:rPr sz="1100" b="0" rtl="1" lang="ar-SA" altLang="en-US">
+              <a:rPr sz="1100" b="0" rtl="0" lang="en-US" altLang="ar-SA">
                 <a:solidFill>
                   <a:srgbClr val="5A5470"/>
                 </a:solidFill>
@@ -54566,7 +54566,7 @@
               </a:spcAft>
             </a:pPr>
             <a:r>
-              <a:rPr sz="1100" b="0" rtl="1" lang="ar-SA" altLang="en-US">
+              <a:rPr sz="1100" b="0" rtl="0" lang="en-US" altLang="ar-SA">
                 <a:solidFill>
                   <a:srgbClr val="5A5470"/>
                 </a:solidFill>
@@ -54977,7 +54977,7 @@
               </a:spcAft>
             </a:pPr>
             <a:r>
-              <a:rPr sz="1100" b="0" rtl="1" lang="ar-SA" altLang="en-US">
+              <a:rPr sz="1100" b="0" rtl="0" lang="en-US" altLang="ar-SA">
                 <a:solidFill>
                   <a:srgbClr val="5A5470"/>
                 </a:solidFill>
@@ -55748,7 +55748,7 @@
               </a:spcAft>
             </a:pPr>
             <a:r>
-              <a:rPr sz="1100" b="0" rtl="1" lang="ar-SA" altLang="en-US">
+              <a:rPr sz="1100" b="0" rtl="0" lang="en-US" altLang="ar-SA">
                 <a:solidFill>
                   <a:srgbClr val="5A5470"/>
                 </a:solidFill>
@@ -55957,7 +55957,7 @@
           </a:bodyPr>
           <a:lstStyle/>
           <a:p>
-            <a:pPr algn="ctr" rtl="1">
+            <a:pPr algn="ctr">
               <a:spcAft>
                 <a:spcPts val="400"/>
               </a:spcAft>
@@ -56131,7 +56131,7 @@
           </a:bodyPr>
           <a:lstStyle/>
           <a:p>
-            <a:pPr algn="ctr" rtl="1">
+            <a:pPr algn="ctr">
               <a:spcAft>
                 <a:spcPts val="400"/>
               </a:spcAft>
@@ -56305,7 +56305,7 @@
           </a:bodyPr>
           <a:lstStyle/>
           <a:p>
-            <a:pPr algn="ctr" rtl="1">
+            <a:pPr algn="ctr">
               <a:spcAft>
                 <a:spcPts val="400"/>
               </a:spcAft>
@@ -56479,7 +56479,7 @@
           </a:bodyPr>
           <a:lstStyle/>
           <a:p>
-            <a:pPr algn="ctr" rtl="1">
+            <a:pPr algn="ctr">
               <a:spcAft>
                 <a:spcPts val="400"/>
               </a:spcAft>
@@ -56831,7 +56831,7 @@
               </a:spcAft>
             </a:pPr>
             <a:r>
-              <a:rPr sz="1100" b="0" rtl="1" lang="ar-SA" altLang="en-US">
+              <a:rPr sz="1100" b="0" rtl="0" lang="en-US" altLang="ar-SA">
                 <a:solidFill>
                   <a:srgbClr val="5A5470"/>
                 </a:solidFill>
@@ -57242,7 +57242,7 @@
               </a:spcAft>
             </a:pPr>
             <a:r>
-              <a:rPr sz="1100" b="0" rtl="1" lang="ar-SA" altLang="en-US">
+              <a:rPr sz="1100" b="0" rtl="0" lang="en-US" altLang="ar-SA">
                 <a:solidFill>
                   <a:srgbClr val="5A5470"/>
                 </a:solidFill>
@@ -57410,7 +57410,7 @@
           </a:bodyPr>
           <a:lstStyle/>
           <a:p>
-            <a:pPr algn="ctr" rtl="1">
+            <a:pPr algn="ctr">
               <a:spcAft>
                 <a:spcPts val="400"/>
               </a:spcAft>
@@ -57584,7 +57584,7 @@
           </a:bodyPr>
           <a:lstStyle/>
           <a:p>
-            <a:pPr algn="ctr" rtl="1">
+            <a:pPr algn="ctr">
               <a:spcAft>
                 <a:spcPts val="400"/>
               </a:spcAft>
@@ -57758,7 +57758,7 @@
           </a:bodyPr>
           <a:lstStyle/>
           <a:p>
-            <a:pPr algn="ctr" rtl="1">
+            <a:pPr algn="ctr">
               <a:spcAft>
                 <a:spcPts val="400"/>
               </a:spcAft>
@@ -57932,7 +57932,7 @@
           </a:bodyPr>
           <a:lstStyle/>
           <a:p>
-            <a:pPr algn="ctr" rtl="1">
+            <a:pPr algn="ctr">
               <a:spcAft>
                 <a:spcPts val="400"/>
               </a:spcAft>
@@ -58284,7 +58284,7 @@
               </a:spcAft>
             </a:pPr>
             <a:r>
-              <a:rPr sz="1100" b="0" rtl="1" lang="ar-SA" altLang="en-US">
+              <a:rPr sz="1100" b="0" rtl="0" lang="en-US" altLang="ar-SA">
                 <a:solidFill>
                   <a:srgbClr val="5A5470"/>
                 </a:solidFill>
@@ -58474,7 +58474,7 @@
           </a:bodyPr>
           <a:lstStyle/>
           <a:p>
-            <a:pPr algn="ctr" rtl="1">
+            <a:pPr algn="ctr">
               <a:spcAft>
                 <a:spcPts val="600"/>
               </a:spcAft>
@@ -58515,7 +58515,7 @@
           </a:bodyPr>
           <a:lstStyle/>
           <a:p>
-            <a:pPr algn="ctr" rtl="1">
+            <a:pPr algn="ctr">
               <a:spcAft>
                 <a:spcPts val="400"/>
               </a:spcAft>
@@ -58670,7 +58670,7 @@
           </a:bodyPr>
           <a:lstStyle/>
           <a:p>
-            <a:pPr algn="ctr" rtl="1">
+            <a:pPr algn="ctr">
               <a:spcAft>
                 <a:spcPts val="600"/>
               </a:spcAft>
@@ -58711,7 +58711,7 @@
           </a:bodyPr>
           <a:lstStyle/>
           <a:p>
-            <a:pPr algn="ctr" rtl="1">
+            <a:pPr algn="ctr">
               <a:spcAft>
                 <a:spcPts val="400"/>
               </a:spcAft>
@@ -59022,7 +59022,7 @@
               </a:spcAft>
             </a:pPr>
             <a:r>
-              <a:rPr sz="1100" b="0" rtl="1" lang="ar-SA" altLang="en-US">
+              <a:rPr sz="1100" b="0" rtl="0" lang="en-US" altLang="ar-SA">
                 <a:solidFill>
                   <a:srgbClr val="5A5470"/>
                 </a:solidFill>
@@ -59433,7 +59433,7 @@
               </a:spcAft>
             </a:pPr>
             <a:r>
-              <a:rPr sz="1100" b="0" rtl="1" lang="ar-SA" altLang="en-US">
+              <a:rPr sz="1100" b="0" rtl="0" lang="en-US" altLang="ar-SA">
                 <a:solidFill>
                   <a:srgbClr val="5A5470"/>
                 </a:solidFill>
@@ -60204,7 +60204,7 @@
               </a:spcAft>
             </a:pPr>
             <a:r>
-              <a:rPr sz="1100" b="0" rtl="1" lang="ar-SA" altLang="en-US">
+              <a:rPr sz="1100" b="0" rtl="0" lang="en-US" altLang="ar-SA">
                 <a:solidFill>
                   <a:srgbClr val="5A5470"/>
                 </a:solidFill>
@@ -60372,7 +60372,7 @@
           </a:bodyPr>
           <a:lstStyle/>
           <a:p>
-            <a:pPr algn="ctr" rtl="1">
+            <a:pPr algn="ctr">
               <a:spcAft>
                 <a:spcPts val="400"/>
               </a:spcAft>
@@ -60546,7 +60546,7 @@
           </a:bodyPr>
           <a:lstStyle/>
           <a:p>
-            <a:pPr algn="ctr" rtl="1">
+            <a:pPr algn="ctr">
               <a:spcAft>
                 <a:spcPts val="400"/>
               </a:spcAft>
@@ -60720,7 +60720,7 @@
           </a:bodyPr>
           <a:lstStyle/>
           <a:p>
-            <a:pPr algn="ctr" rtl="1">
+            <a:pPr algn="ctr">
               <a:spcAft>
                 <a:spcPts val="400"/>
               </a:spcAft>
@@ -60894,7 +60894,7 @@
           </a:bodyPr>
           <a:lstStyle/>
           <a:p>
-            <a:pPr algn="ctr" rtl="1">
+            <a:pPr algn="ctr">
               <a:spcAft>
                 <a:spcPts val="400"/>
               </a:spcAft>
@@ -61246,7 +61246,7 @@
               </a:spcAft>
             </a:pPr>
             <a:r>
-              <a:rPr sz="1100" b="0" rtl="1" lang="ar-SA" altLang="en-US">
+              <a:rPr sz="1100" b="0" rtl="0" lang="en-US" altLang="ar-SA">
                 <a:solidFill>
                   <a:srgbClr val="5A5470"/>
                 </a:solidFill>
@@ -62017,7 +62017,7 @@
               </a:spcAft>
             </a:pPr>
             <a:r>
-              <a:rPr sz="1100" b="0" rtl="1" lang="ar-SA" altLang="en-US">
+              <a:rPr sz="1100" b="0" rtl="0" lang="en-US" altLang="ar-SA">
                 <a:solidFill>
                   <a:srgbClr val="5A5470"/>
                 </a:solidFill>
@@ -62788,7 +62788,7 @@
               </a:spcAft>
             </a:pPr>
             <a:r>
-              <a:rPr sz="1100" b="0" rtl="1" lang="ar-SA" altLang="en-US">
+              <a:rPr sz="1100" b="0" rtl="0" lang="en-US" altLang="ar-SA">
                 <a:solidFill>
                   <a:srgbClr val="5A5470"/>
                 </a:solidFill>
@@ -62997,7 +62997,7 @@
           </a:bodyPr>
           <a:lstStyle/>
           <a:p>
-            <a:pPr algn="ctr" rtl="1">
+            <a:pPr algn="ctr">
               <a:spcAft>
                 <a:spcPts val="400"/>
               </a:spcAft>
@@ -63171,7 +63171,7 @@
           </a:bodyPr>
           <a:lstStyle/>
           <a:p>
-            <a:pPr algn="ctr" rtl="1">
+            <a:pPr algn="ctr">
               <a:spcAft>
                 <a:spcPts val="400"/>
               </a:spcAft>
@@ -63345,7 +63345,7 @@
           </a:bodyPr>
           <a:lstStyle/>
           <a:p>
-            <a:pPr algn="ctr" rtl="1">
+            <a:pPr algn="ctr">
               <a:spcAft>
                 <a:spcPts val="400"/>
               </a:spcAft>
@@ -63519,7 +63519,7 @@
           </a:bodyPr>
           <a:lstStyle/>
           <a:p>
-            <a:pPr algn="ctr" rtl="1">
+            <a:pPr algn="ctr">
               <a:spcAft>
                 <a:spcPts val="400"/>
               </a:spcAft>
@@ -63693,7 +63693,7 @@
           </a:bodyPr>
           <a:lstStyle/>
           <a:p>
-            <a:pPr algn="ctr" rtl="1">
+            <a:pPr algn="ctr">
               <a:spcAft>
                 <a:spcPts val="400"/>
               </a:spcAft>
@@ -64045,7 +64045,7 @@
               </a:spcAft>
             </a:pPr>
             <a:r>
-              <a:rPr sz="1100" b="0" rtl="1" lang="ar-SA" altLang="en-US">
+              <a:rPr sz="1100" b="0" rtl="0" lang="en-US" altLang="ar-SA">
                 <a:solidFill>
                   <a:srgbClr val="5A5470"/>
                 </a:solidFill>
@@ -64086,7 +64086,7 @@
               </a:spcAft>
             </a:pPr>
             <a:r>
-              <a:rPr sz="3200" b="1" rtl="1" lang="ar-SA" altLang="en-US">
+              <a:rPr sz="2800" b="1" rtl="1" lang="ar-SA" altLang="en-US">
                 <a:solidFill>
                   <a:srgbClr val="5234B7"/>
                 </a:solidFill>
@@ -64816,7 +64816,7 @@
               </a:spcAft>
             </a:pPr>
             <a:r>
-              <a:rPr sz="1100" b="0" rtl="1" lang="ar-SA" altLang="en-US">
+              <a:rPr sz="1100" b="0" rtl="0" lang="en-US" altLang="ar-SA">
                 <a:solidFill>
                   <a:srgbClr val="5A5470"/>
                 </a:solidFill>
@@ -65587,7 +65587,7 @@
               </a:spcAft>
             </a:pPr>
             <a:r>
-              <a:rPr sz="1100" b="0" rtl="1" lang="ar-SA" altLang="en-US">
+              <a:rPr sz="1100" b="0" rtl="0" lang="en-US" altLang="ar-SA">
                 <a:solidFill>
                   <a:srgbClr val="5A5470"/>
                 </a:solidFill>
@@ -65818,7 +65818,7 @@
           </a:bodyPr>
           <a:lstStyle/>
           <a:p>
-            <a:pPr algn="ctr" rtl="1">
+            <a:pPr algn="ctr">
               <a:spcAft>
                 <a:spcPts val="600"/>
               </a:spcAft>
@@ -65859,7 +65859,7 @@
           </a:bodyPr>
           <a:lstStyle/>
           <a:p>
-            <a:pPr algn="ctr" rtl="1">
+            <a:pPr algn="ctr">
               <a:spcAft>
                 <a:spcPts val="400"/>
               </a:spcAft>
@@ -66014,7 +66014,7 @@
           </a:bodyPr>
           <a:lstStyle/>
           <a:p>
-            <a:pPr algn="ctr" rtl="1">
+            <a:pPr algn="ctr">
               <a:spcAft>
                 <a:spcPts val="600"/>
               </a:spcAft>
@@ -66055,7 +66055,7 @@
           </a:bodyPr>
           <a:lstStyle/>
           <a:p>
-            <a:pPr algn="ctr" rtl="1">
+            <a:pPr algn="ctr">
               <a:spcAft>
                 <a:spcPts val="400"/>
               </a:spcAft>
@@ -66210,7 +66210,7 @@
           </a:bodyPr>
           <a:lstStyle/>
           <a:p>
-            <a:pPr algn="ctr" rtl="1">
+            <a:pPr algn="ctr">
               <a:spcAft>
                 <a:spcPts val="600"/>
               </a:spcAft>
@@ -66251,7 +66251,7 @@
           </a:bodyPr>
           <a:lstStyle/>
           <a:p>
-            <a:pPr algn="ctr" rtl="1">
+            <a:pPr algn="ctr">
               <a:spcAft>
                 <a:spcPts val="400"/>
               </a:spcAft>
@@ -66386,7 +66386,7 @@
           </a:bodyPr>
           <a:lstStyle/>
           <a:p>
-            <a:pPr algn="ctr" rtl="1">
+            <a:pPr algn="ctr">
               <a:spcAft>
                 <a:spcPts val="600"/>
               </a:spcAft>
@@ -66427,7 +66427,7 @@
           </a:bodyPr>
           <a:lstStyle/>
           <a:p>
-            <a:pPr algn="ctr" rtl="1">
+            <a:pPr algn="ctr">
               <a:spcAft>
                 <a:spcPts val="600"/>
               </a:spcAft>
@@ -66468,7 +66468,7 @@
           </a:bodyPr>
           <a:lstStyle/>
           <a:p>
-            <a:pPr algn="ctr" rtl="1">
+            <a:pPr algn="ctr">
               <a:spcAft>
                 <a:spcPts val="400"/>
               </a:spcAft>
@@ -66670,7 +66670,7 @@
               </a:spcAft>
             </a:pPr>
             <a:r>
-              <a:rPr sz="1100" b="0" rtl="1" lang="ar-SA" altLang="en-US">
+              <a:rPr sz="1100" b="0" rtl="0" lang="en-US" altLang="ar-SA">
                 <a:solidFill>
                   <a:srgbClr val="5A5470"/>
                 </a:solidFill>
@@ -66975,7 +66975,7 @@
               </a:spcAft>
             </a:pPr>
             <a:r>
-              <a:rPr sz="1100" b="0" rtl="1" lang="ar-SA" altLang="en-US">
+              <a:rPr sz="1100" b="0" rtl="0" lang="en-US" altLang="ar-SA">
                 <a:solidFill>
                   <a:srgbClr val="5A5470"/>
                 </a:solidFill>

</xml_diff>